<commit_message>
Liste complète de questions Moodle et adaptations modules ABS et GEN
</commit_message>
<xml_diff>
--- a/_slides/slides_de_cours/06. ABS_slides.pptx
+++ b/_slides/slides_de_cours/06. ABS_slides.pptx
@@ -40,6 +40,7 @@
     <p:sldId id="674" r:id="rId28"/>
     <p:sldId id="675" r:id="rId29"/>
     <p:sldId id="676" r:id="rId30"/>
+    <p:sldId id="696" r:id="rId54"/>
     <p:sldId id="677" r:id="rId31"/>
     <p:sldId id="678" r:id="rId32"/>
     <p:sldId id="679" r:id="rId33"/>
@@ -5045,6 +5046,91 @@
           </p:cNvSpPr>
           <p:nvPr>
             <p:ph type="sldNum" sz="quarter" idx="5"/>
+          </p:nvPr>
+        </p:nvSpPr>
+        <p:spPr/>
+      </p:sp>
+    </p:spTree>
+  </p:cSld>
+  <p:clrMapOvr>
+    <a:masterClrMapping/>
+  </p:clrMapOvr>
+</p:notes>
+</file>
+
+<file path=ppt/notesSlides/notesSlide47.xml><?xml version="1.0" encoding="utf-8"?>
+<p:notes xmlns:a="http://schemas.openxmlformats.org/drawingml/2006/main" xmlns:p="http://schemas.openxmlformats.org/presentationml/2006/main" xmlns:r="http://schemas.openxmlformats.org/officeDocument/2006/relationships">
+  <p:cSld>
+    <p:spTree>
+      <p:nvGrpSpPr>
+        <p:cNvPr id="1" name=""/>
+        <p:cNvGrpSpPr/>
+        <p:nvPr/>
+      </p:nvGrpSpPr>
+      <p:grpSpPr>
+        <a:xfrm>
+          <a:off x="0" y="0"/>
+          <a:ext cx="0" cy="0"/>
+          <a:chOff x="0" y="0"/>
+          <a:chExt cx="0" cy="0"/>
+        </a:xfrm>
+      </p:grpSpPr>
+      <p:sp>
+        <p:nvSpPr>
+          <p:cNvPr id="2" name="Slide Image Placeholder 1"/>
+          <p:cNvSpPr>
+            <a:spLocks noGrp="1"/>
+          </p:cNvSpPr>
+          <p:nvPr>
+            <p:ph type="sldImg" idx="2"/>
+          </p:nvPr>
+        </p:nvSpPr>
+        <p:spPr/>
+      </p:sp>
+      <p:sp>
+        <p:nvSpPr>
+          <p:cNvPr id="3" name="Notes Placeholder 2"/>
+          <p:cNvSpPr>
+            <a:spLocks noGrp="1"/>
+          </p:cNvSpPr>
+          <p:nvPr>
+            <p:ph type="body" idx="3" sz="quarter"/>
+          </p:nvPr>
+        </p:nvSpPr>
+        <p:spPr/>
+        <p:txBody>
+          <a:bodyPr/>
+          <a:lstStyle/>
+          <a:p>
+            <a:r>
+              <a:t>Le cas où la même méthode est redéfinie à plusieurs étages. truc() est écrite dans A, redéfinie dans C et dans D.</a:t>
+            </a:r>
+          </a:p>
+          <a:p>
+            <a:r>
+              <a:t>Règle : Java part de la classe réelle de l'objet, et remonte jusqu'à la première classe qui écrit la méthode. Un objet A exécute celle de A ; B, celle de A, puisqu'il ne l'écrit pas ; C, la sienne ; D, la sienne ; E, celle de A, en passant par B ; F, celle de C.</a:t>
+            </a:r>
+          </a:p>
+          <a:p>
+            <a:r>
+              <a:t>Le type de la variable ne change rien : A x = new F(); puis x.truc() exécute la version de C.</a:t>
+            </a:r>
+          </a:p>
+          <a:p>
+            <a:r>
+              <a:t>Dans D, super.truc() désigne la version dont B dispose : B ne l'écrit pas, c'est donc celle de A. super ne désigne pas forcément une méthode écrite dans la mère directe, mais la plus proche en remontant.</a:t>
+            </a:r>
+          </a:p>
+        </p:txBody>
+      </p:sp>
+      <p:sp>
+        <p:nvSpPr>
+          <p:cNvPr id="4" name="Slide Number Placeholder 3"/>
+          <p:cNvSpPr>
+            <a:spLocks noGrp="1"/>
+          </p:cNvSpPr>
+          <p:nvPr>
+            <p:ph type="sldNum" idx="5" sz="quarter"/>
           </p:nvPr>
         </p:nvSpPr>
         <p:spPr/>
@@ -21441,6 +21527,191 @@
 </file>
 
 <file path=ppt/slides/slide30.xml><?xml version="1.0" encoding="utf-8"?>
+<p:sld xmlns:a="http://schemas.openxmlformats.org/drawingml/2006/main" xmlns:p="http://schemas.openxmlformats.org/presentationml/2006/main" xmlns:r="http://schemas.openxmlformats.org/officeDocument/2006/relationships">
+  <p:cSld>
+    <p:spTree>
+      <p:nvGrpSpPr>
+        <p:cNvPr id="1" name=""/>
+        <p:cNvGrpSpPr/>
+        <p:nvPr/>
+      </p:nvGrpSpPr>
+      <p:grpSpPr/>
+      <p:sp>
+        <p:nvSpPr>
+          <p:cNvPr id="2" name="Title 1"/>
+          <p:cNvSpPr>
+            <a:spLocks noGrp="1"/>
+          </p:cNvSpPr>
+          <p:nvPr>
+            <p:ph type="title"/>
+          </p:nvPr>
+        </p:nvSpPr>
+        <p:spPr/>
+        <p:txBody>
+          <a:bodyPr>
+            <a:noAutofit/>
+          </a:bodyPr>
+          <a:lstStyle/>
+          <a:p>
+            <a:r>
+              <a:rPr sz="4000"/>
+              <a:t>Quelle version s'exécute ?</a:t>
+            </a:r>
+          </a:p>
+        </p:txBody>
+      </p:sp>
+      <p:sp>
+        <p:nvSpPr>
+          <p:cNvPr id="18" name="Repere de section"/>
+          <p:cNvSpPr txBox="1"/>
+          <p:nvPr/>
+        </p:nvSpPr>
+        <p:spPr>
+          <a:xfrm>
+            <a:off x="6583680" y="6382512"/>
+            <a:ext cx="4480560" cy="320040"/>
+          </a:xfrm>
+          <a:prstGeom prst="rect">
+            <a:avLst/>
+          </a:prstGeom>
+          <a:noFill/>
+        </p:spPr>
+        <p:txBody>
+          <a:bodyPr wrap="none" tIns="0" bIns="0">
+            <a:spAutoFit/>
+          </a:bodyPr>
+          <a:lstStyle/>
+          <a:p>
+            <a:pPr algn="r"/>
+            <a:r>
+              <a:rPr sz="1100">
+                <a:solidFill>
+                  <a:srgbClr val="BCBEC4"/>
+                </a:solidFill>
+              </a:rPr>
+              <a:t>ABS · </a:t>
+            </a:r>
+            <a:r>
+              <a:rPr sz="1100" b="1">
+                <a:solidFill>
+                  <a:schemeClr val="accent4"/>
+                </a:solidFill>
+              </a:rPr>
+              <a:t>5. Le polymorphisme</a:t>
+            </a:r>
+          </a:p>
+        </p:txBody>
+      </p:sp>
+      <p:pic>
+        <p:nvPicPr>
+          <p:cNvPr id="19" name="Picture 18" descr="abs-chaine.png"/>
+          <p:cNvPicPr>
+            <a:picLocks noChangeAspect="1"/>
+          </p:cNvPicPr>
+          <p:nvPr/>
+        </p:nvPicPr>
+        <p:blipFill>
+          <a:blip r:embed="rId2"/>
+          <a:stretch>
+            <a:fillRect/>
+          </a:stretch>
+        </p:blipFill>
+        <p:spPr>
+          <a:xfrm>
+            <a:off x="560000" y="1450000"/>
+            <a:ext cx="6200000" cy="2314666"/>
+          </a:xfrm>
+          <a:prstGeom prst="rect">
+            <a:avLst/>
+          </a:prstGeom>
+        </p:spPr>
+      </p:pic>
+      <p:sp>
+        <p:nvSpPr>
+          <p:cNvPr id="20" name="TextBox 19"/>
+          <p:cNvSpPr txBox="1"/>
+          <p:nvPr/>
+        </p:nvSpPr>
+        <p:spPr>
+          <a:xfrm>
+            <a:off x="7060000" y="1600000"/>
+            <a:ext cx="4492000" cy="3500000"/>
+          </a:xfrm>
+          <a:prstGeom prst="rect">
+            <a:avLst/>
+          </a:prstGeom>
+          <a:noFill/>
+        </p:spPr>
+        <p:txBody>
+          <a:bodyPr wrap="square">
+            <a:spAutoFit/>
+          </a:bodyPr>
+          <a:lstStyle/>
+          <a:p>
+            <a:pPr>
+              <a:spcAft>
+                <a:spcPts val="1200"/>
+              </a:spcAft>
+            </a:pPr>
+            <a:r>
+              <a:rPr sz="2000">
+                <a:solidFill>
+                  <a:srgbClr val="FFFFFF"/>
+                </a:solidFill>
+              </a:rPr>
+              <a:t>On part de la classe réelle de l'objet</a:t>
+            </a:r>
+          </a:p>
+          <a:p>
+            <a:pPr>
+              <a:spcAft>
+                <a:spcPts val="1200"/>
+              </a:spcAft>
+            </a:pPr>
+            <a:r>
+              <a:rPr sz="2000">
+                <a:solidFill>
+                  <a:srgbClr val="FFFFFF"/>
+                </a:solidFill>
+              </a:rPr>
+              <a:t>On remonte jusqu'à la première classe qui écrit la méthode</a:t>
+            </a:r>
+          </a:p>
+          <a:p>
+            <a:pPr>
+              <a:spcAft>
+                <a:spcPts val="1200"/>
+              </a:spcAft>
+            </a:pPr>
+            <a:r>
+              <a:rPr sz="2000">
+                <a:solidFill>
+                  <a:schemeClr val="accent4"/>
+                </a:solidFill>
+                <a:latin typeface="Consolas"/>
+              </a:rPr>
+              <a:t>super.truc()</a:t>
+            </a:r>
+            <a:r>
+              <a:rPr sz="2000">
+                <a:solidFill>
+                  <a:srgbClr val="FFFFFF"/>
+                </a:solidFill>
+              </a:rPr>
+              <a:t> : la version la plus proche au-dessus</a:t>
+            </a:r>
+          </a:p>
+        </p:txBody>
+      </p:sp>
+    </p:spTree>
+  </p:cSld>
+  <p:clrMapOvr>
+    <a:masterClrMapping/>
+  </p:clrMapOvr>
+</p:sld>
+</file>
+
+<file path=ppt/slides/slide31.xml><?xml version="1.0" encoding="utf-8"?>
 <p:sld xmlns:a="http://schemas.openxmlformats.org/drawingml/2006/main" xmlns:r="http://schemas.openxmlformats.org/officeDocument/2006/relationships" xmlns:p="http://schemas.openxmlformats.org/presentationml/2006/main">
   <p:cSld>
     <p:spTree>
@@ -21980,7 +22251,7 @@
 </p:sld>
 </file>
 
-<file path=ppt/slides/slide31.xml><?xml version="1.0" encoding="utf-8"?>
+<file path=ppt/slides/slide32.xml><?xml version="1.0" encoding="utf-8"?>
 <p:sld xmlns:a="http://schemas.openxmlformats.org/drawingml/2006/main" xmlns:r="http://schemas.openxmlformats.org/officeDocument/2006/relationships" xmlns:p="http://schemas.openxmlformats.org/presentationml/2006/main">
   <p:cSld>
     <p:spTree>
@@ -22298,7 +22569,7 @@
 </p:sld>
 </file>
 
-<file path=ppt/slides/slide32.xml><?xml version="1.0" encoding="utf-8"?>
+<file path=ppt/slides/slide33.xml><?xml version="1.0" encoding="utf-8"?>
 <p:sld xmlns:a="http://schemas.openxmlformats.org/drawingml/2006/main" xmlns:r="http://schemas.openxmlformats.org/officeDocument/2006/relationships" xmlns:p="http://schemas.openxmlformats.org/presentationml/2006/main">
   <p:cSld>
     <p:spTree>
@@ -22459,7 +22730,7 @@
 </p:sld>
 </file>
 
-<file path=ppt/slides/slide33.xml><?xml version="1.0" encoding="utf-8"?>
+<file path=ppt/slides/slide34.xml><?xml version="1.0" encoding="utf-8"?>
 <p:sld xmlns:a="http://schemas.openxmlformats.org/drawingml/2006/main" xmlns:r="http://schemas.openxmlformats.org/officeDocument/2006/relationships" xmlns:p="http://schemas.openxmlformats.org/presentationml/2006/main">
   <p:cSld>
     <p:spTree>
@@ -23188,7 +23459,7 @@
 </p:sld>
 </file>
 
-<file path=ppt/slides/slide34.xml><?xml version="1.0" encoding="utf-8"?>
+<file path=ppt/slides/slide35.xml><?xml version="1.0" encoding="utf-8"?>
 <p:sld xmlns:a="http://schemas.openxmlformats.org/drawingml/2006/main" xmlns:r="http://schemas.openxmlformats.org/officeDocument/2006/relationships" xmlns:p="http://schemas.openxmlformats.org/presentationml/2006/main">
   <p:cSld>
     <p:spTree>
@@ -24259,7 +24530,7 @@
 </p:sld>
 </file>
 
-<file path=ppt/slides/slide35.xml><?xml version="1.0" encoding="utf-8"?>
+<file path=ppt/slides/slide36.xml><?xml version="1.0" encoding="utf-8"?>
 <p:sld xmlns:a="http://schemas.openxmlformats.org/drawingml/2006/main" xmlns:r="http://schemas.openxmlformats.org/officeDocument/2006/relationships" xmlns:p="http://schemas.openxmlformats.org/presentationml/2006/main">
   <p:cSld>
     <p:spTree>
@@ -24920,227 +25191,6 @@
 </p:sld>
 </file>
 
-<file path=ppt/slides/slide36.xml><?xml version="1.0" encoding="utf-8"?>
-<p:sld xmlns:a="http://schemas.openxmlformats.org/drawingml/2006/main" xmlns:r="http://schemas.openxmlformats.org/officeDocument/2006/relationships" xmlns:p="http://schemas.openxmlformats.org/presentationml/2006/main">
-  <p:cSld>
-    <p:spTree>
-      <p:nvGrpSpPr>
-        <p:cNvPr id="1" name=""/>
-        <p:cNvGrpSpPr/>
-        <p:nvPr/>
-      </p:nvGrpSpPr>
-      <p:grpSpPr>
-        <a:xfrm>
-          <a:off x="0" y="0"/>
-          <a:ext cx="0" cy="0"/>
-          <a:chOff x="0" y="0"/>
-          <a:chExt cx="0" cy="0"/>
-        </a:xfrm>
-      </p:grpSpPr>
-      <p:sp>
-        <p:nvSpPr>
-          <p:cNvPr id="2" name="Title 1"/>
-          <p:cNvSpPr>
-            <a:spLocks noGrp="1"/>
-          </p:cNvSpPr>
-          <p:nvPr>
-            <p:ph type="title"/>
-          </p:nvPr>
-        </p:nvSpPr>
-        <p:spPr/>
-        <p:txBody>
-          <a:bodyPr>
-            <a:noAutofit/>
-          </a:bodyPr>
-          <a:lstStyle/>
-          <a:p>
-            <a:r>
-              <a:rPr sz="4000"/>
-              <a:t>Pourquoi </a:t>
-            </a:r>
-            <a:r>
-              <a:rPr sz="3400">
-                <a:solidFill>
-                  <a:schemeClr val="accent4"/>
-                </a:solidFill>
-                <a:latin typeface="Consolas"/>
-              </a:rPr>
-              <a:t>protected</a:t>
-            </a:r>
-          </a:p>
-        </p:txBody>
-      </p:sp>
-      <p:sp>
-        <p:nvSpPr>
-          <p:cNvPr id="3" name="Content Placeholder 2"/>
-          <p:cNvSpPr>
-            <a:spLocks noGrp="1"/>
-          </p:cNvSpPr>
-          <p:nvPr>
-            <p:ph idx="1"/>
-          </p:nvPr>
-        </p:nvSpPr>
-        <p:spPr>
-          <a:xfrm>
-            <a:off x="640080" y="1371600"/>
-            <a:ext cx="10881360" cy="4800600"/>
-          </a:xfrm>
-        </p:spPr>
-        <p:txBody>
-          <a:bodyPr/>
-          <a:lstStyle/>
-          <a:p>
-            <a:pPr marL="0" indent="0">
-              <a:spcAft>
-                <a:spcPts val="1000"/>
-              </a:spcAft>
-              <a:buNone/>
-            </a:pPr>
-            <a:r>
-              <a:rPr sz="2800"/>
-              <a:t>Une méthode que seule la classe mère appelle n'a pas à être </a:t>
-            </a:r>
-            <a:r>
-              <a:rPr sz="2400">
-                <a:solidFill>
-                  <a:schemeClr val="accent4"/>
-                </a:solidFill>
-                <a:latin typeface="Consolas"/>
-              </a:rPr>
-              <a:t>public</a:t>
-            </a:r>
-          </a:p>
-          <a:p>
-            <a:pPr marL="0" indent="0">
-              <a:spcAft>
-                <a:spcPts val="1000"/>
-              </a:spcAft>
-              <a:buNone/>
-            </a:pPr>
-            <a:r>
-              <a:rPr sz="2800"/>
-              <a:t>Le modificateur </a:t>
-            </a:r>
-            <a:r>
-              <a:rPr sz="2400">
-                <a:solidFill>
-                  <a:schemeClr val="accent4"/>
-                </a:solidFill>
-                <a:latin typeface="Consolas"/>
-              </a:rPr>
-              <a:t>protected</a:t>
-            </a:r>
-            <a:r>
-              <a:rPr sz="2800"/>
-              <a:t> l'ouvre aux sous-classes, et la ferme au reste</a:t>
-            </a:r>
-          </a:p>
-          <a:p>
-            <a:pPr marL="0" indent="0">
-              <a:spcAft>
-                <a:spcPts val="1000"/>
-              </a:spcAft>
-              <a:buNone/>
-            </a:pPr>
-            <a:r>
-              <a:rPr sz="2800"/>
-              <a:t>Une méthode abstraite </a:t>
-            </a:r>
-            <a:r>
-              <a:rPr sz="2400">
-                <a:solidFill>
-                  <a:schemeClr val="accent4"/>
-                </a:solidFill>
-                <a:latin typeface="Consolas"/>
-              </a:rPr>
-              <a:t>protected</a:t>
-            </a:r>
-            <a:r>
-              <a:rPr sz="2800"/>
-              <a:t> reste redéfinissable par les sous-classes</a:t>
-            </a:r>
-          </a:p>
-        </p:txBody>
-      </p:sp>
-      <p:sp>
-        <p:nvSpPr>
-          <p:cNvPr id="17" name="Espace réservé du numéro de diapositive 4">
-            <a:extLst>
-              <a:ext uri="{FF2B5EF4-FFF2-40B4-BE49-F238E27FC236}">
-                <a16:creationId xmlns:a16="http://schemas.microsoft.com/office/drawing/2014/main" id="{BD53DBCC-04B3-4199-D3FD-FAA13499E3E8}"/>
-              </a:ext>
-            </a:extLst>
-          </p:cNvPr>
-          <p:cNvSpPr>
-            <a:spLocks noGrp="1"/>
-          </p:cNvSpPr>
-          <p:nvPr>
-            <p:ph type="sldNum" sz="quarter" idx="4"/>
-          </p:nvPr>
-        </p:nvSpPr>
-        <p:spPr/>
-        <p:txBody>
-          <a:bodyPr/>
-          <a:lstStyle/>
-          <a:p>
-            <a:fld id="{33C783E2-4793-4F48-A271-51A73CC37D74}" type="slidenum">
-              <a:rPr lang="fr-FR" smtClean="0"/>
-              <a:t>36</a:t>
-            </a:fld>
-            <a:endParaRPr lang="fr-FR"/>
-          </a:p>
-        </p:txBody>
-      </p:sp>
-      <p:sp>
-        <p:nvSpPr>
-          <p:cNvPr id="18" name="Repere de section"/>
-          <p:cNvSpPr txBox="1"/>
-          <p:nvPr/>
-        </p:nvSpPr>
-        <p:spPr>
-          <a:xfrm>
-            <a:off x="6583680" y="6382512"/>
-            <a:ext cx="4480560" cy="320040"/>
-          </a:xfrm>
-          <a:prstGeom prst="rect">
-            <a:avLst/>
-          </a:prstGeom>
-          <a:noFill/>
-        </p:spPr>
-        <p:txBody>
-          <a:bodyPr wrap="none" tIns="0" bIns="0">
-            <a:spAutoFit/>
-          </a:bodyPr>
-          <a:lstStyle/>
-          <a:p>
-            <a:pPr algn="r"/>
-            <a:r>
-              <a:rPr sz="1100">
-                <a:solidFill>
-                  <a:srgbClr val="BCBEC4"/>
-                </a:solidFill>
-              </a:rPr>
-              <a:t>ABS · </a:t>
-            </a:r>
-            <a:r>
-              <a:rPr sz="1100" b="1">
-                <a:solidFill>
-                  <a:schemeClr val="accent4"/>
-                </a:solidFill>
-              </a:rPr>
-              <a:t>6. La mère appelle la fille</a:t>
-            </a:r>
-          </a:p>
-        </p:txBody>
-      </p:sp>
-    </p:spTree>
-  </p:cSld>
-  <p:clrMapOvr>
-    <a:masterClrMapping/>
-  </p:clrMapOvr>
-</p:sld>
-</file>
-
 <file path=ppt/slides/slide37.xml><?xml version="1.0" encoding="utf-8"?>
 <p:sld xmlns:a="http://schemas.openxmlformats.org/drawingml/2006/main" xmlns:r="http://schemas.openxmlformats.org/officeDocument/2006/relationships" xmlns:p="http://schemas.openxmlformats.org/presentationml/2006/main">
   <p:cSld>
@@ -25177,7 +25227,16 @@
           <a:p>
             <a:r>
               <a:rPr sz="4000"/>
-              <a:t>La mesure de la réussite</a:t>
+              <a:t>Pourquoi </a:t>
+            </a:r>
+            <a:r>
+              <a:rPr sz="3400">
+                <a:solidFill>
+                  <a:schemeClr val="accent4"/>
+                </a:solidFill>
+                <a:latin typeface="Consolas"/>
+              </a:rPr>
+              <a:t>protected</a:t>
             </a:r>
           </a:p>
         </p:txBody>
@@ -25210,7 +25269,16 @@
             </a:pPr>
             <a:r>
               <a:rPr sz="2800"/>
-              <a:t>La nouvelle classe devrait faire une vingtaine de lignes, dont trois méthodes de deux lignes</a:t>
+              <a:t>Une méthode que seule la classe mère appelle n'a pas à être </a:t>
+            </a:r>
+            <a:r>
+              <a:rPr sz="2400">
+                <a:solidFill>
+                  <a:schemeClr val="accent4"/>
+                </a:solidFill>
+                <a:latin typeface="Consolas"/>
+              </a:rPr>
+              <a:t>public</a:t>
             </a:r>
           </a:p>
           <a:p>
@@ -25222,7 +25290,20 @@
             </a:pPr>
             <a:r>
               <a:rPr sz="2800"/>
-              <a:t>Si elle est plus longue, c'est que quelque chose a été recopié de la mère</a:t>
+              <a:t>Le modificateur </a:t>
+            </a:r>
+            <a:r>
+              <a:rPr sz="2400">
+                <a:solidFill>
+                  <a:schemeClr val="accent4"/>
+                </a:solidFill>
+                <a:latin typeface="Consolas"/>
+              </a:rPr>
+              <a:t>protected</a:t>
+            </a:r>
+            <a:r>
+              <a:rPr sz="2800"/>
+              <a:t> l'ouvre aux sous-classes, et la ferme au reste</a:t>
             </a:r>
           </a:p>
           <a:p>
@@ -25234,7 +25315,7 @@
             </a:pPr>
             <a:r>
               <a:rPr sz="2800"/>
-              <a:t>Et le programme ne contient ni </a:t>
+              <a:t>Une méthode abstraite </a:t>
             </a:r>
             <a:r>
               <a:rPr sz="2400">
@@ -25243,11 +25324,11 @@
                 </a:solidFill>
                 <a:latin typeface="Consolas"/>
               </a:rPr>
-              <a:t>instanceof</a:t>
+              <a:t>protected</a:t>
             </a:r>
             <a:r>
               <a:rPr sz="2800"/>
-              <a:t>, ni condition sur la banque</a:t>
+              <a:t> reste redéfinissable par les sous-classes</a:t>
             </a:r>
           </a:p>
         </p:txBody>
@@ -25275,7 +25356,7 @@
           <a:p>
             <a:fld id="{33C783E2-4793-4F48-A271-51A73CC37D74}" type="slidenum">
               <a:rPr lang="fr-FR" smtClean="0"/>
-              <a:t>37</a:t>
+              <a:t>36</a:t>
             </a:fld>
             <a:endParaRPr lang="fr-FR"/>
           </a:p>
@@ -25332,6 +25413,196 @@
 </file>
 
 <file path=ppt/slides/slide38.xml><?xml version="1.0" encoding="utf-8"?>
+<p:sld xmlns:a="http://schemas.openxmlformats.org/drawingml/2006/main" xmlns:r="http://schemas.openxmlformats.org/officeDocument/2006/relationships" xmlns:p="http://schemas.openxmlformats.org/presentationml/2006/main">
+  <p:cSld>
+    <p:spTree>
+      <p:nvGrpSpPr>
+        <p:cNvPr id="1" name=""/>
+        <p:cNvGrpSpPr/>
+        <p:nvPr/>
+      </p:nvGrpSpPr>
+      <p:grpSpPr>
+        <a:xfrm>
+          <a:off x="0" y="0"/>
+          <a:ext cx="0" cy="0"/>
+          <a:chOff x="0" y="0"/>
+          <a:chExt cx="0" cy="0"/>
+        </a:xfrm>
+      </p:grpSpPr>
+      <p:sp>
+        <p:nvSpPr>
+          <p:cNvPr id="2" name="Title 1"/>
+          <p:cNvSpPr>
+            <a:spLocks noGrp="1"/>
+          </p:cNvSpPr>
+          <p:nvPr>
+            <p:ph type="title"/>
+          </p:nvPr>
+        </p:nvSpPr>
+        <p:spPr/>
+        <p:txBody>
+          <a:bodyPr>
+            <a:noAutofit/>
+          </a:bodyPr>
+          <a:lstStyle/>
+          <a:p>
+            <a:r>
+              <a:rPr sz="4000"/>
+              <a:t>La mesure de la réussite</a:t>
+            </a:r>
+          </a:p>
+        </p:txBody>
+      </p:sp>
+      <p:sp>
+        <p:nvSpPr>
+          <p:cNvPr id="3" name="Content Placeholder 2"/>
+          <p:cNvSpPr>
+            <a:spLocks noGrp="1"/>
+          </p:cNvSpPr>
+          <p:nvPr>
+            <p:ph idx="1"/>
+          </p:nvPr>
+        </p:nvSpPr>
+        <p:spPr>
+          <a:xfrm>
+            <a:off x="640080" y="1371600"/>
+            <a:ext cx="10881360" cy="4800600"/>
+          </a:xfrm>
+        </p:spPr>
+        <p:txBody>
+          <a:bodyPr/>
+          <a:lstStyle/>
+          <a:p>
+            <a:pPr marL="0" indent="0">
+              <a:spcAft>
+                <a:spcPts val="1000"/>
+              </a:spcAft>
+              <a:buNone/>
+            </a:pPr>
+            <a:r>
+              <a:rPr sz="2800"/>
+              <a:t>La nouvelle classe devrait faire une vingtaine de lignes, dont trois méthodes de deux lignes</a:t>
+            </a:r>
+          </a:p>
+          <a:p>
+            <a:pPr marL="0" indent="0">
+              <a:spcAft>
+                <a:spcPts val="1000"/>
+              </a:spcAft>
+              <a:buNone/>
+            </a:pPr>
+            <a:r>
+              <a:rPr sz="2800"/>
+              <a:t>Si elle est plus longue, c'est que quelque chose a été recopié de la mère</a:t>
+            </a:r>
+          </a:p>
+          <a:p>
+            <a:pPr marL="0" indent="0">
+              <a:spcAft>
+                <a:spcPts val="1000"/>
+              </a:spcAft>
+              <a:buNone/>
+            </a:pPr>
+            <a:r>
+              <a:rPr sz="2800"/>
+              <a:t>Et le programme ne contient ni </a:t>
+            </a:r>
+            <a:r>
+              <a:rPr sz="2400">
+                <a:solidFill>
+                  <a:schemeClr val="accent4"/>
+                </a:solidFill>
+                <a:latin typeface="Consolas"/>
+              </a:rPr>
+              <a:t>instanceof</a:t>
+            </a:r>
+            <a:r>
+              <a:rPr sz="2800"/>
+              <a:t>, ni condition sur la banque</a:t>
+            </a:r>
+          </a:p>
+        </p:txBody>
+      </p:sp>
+      <p:sp>
+        <p:nvSpPr>
+          <p:cNvPr id="17" name="Espace réservé du numéro de diapositive 4">
+            <a:extLst>
+              <a:ext uri="{FF2B5EF4-FFF2-40B4-BE49-F238E27FC236}">
+                <a16:creationId xmlns:a16="http://schemas.microsoft.com/office/drawing/2014/main" id="{BD53DBCC-04B3-4199-D3FD-FAA13499E3E8}"/>
+              </a:ext>
+            </a:extLst>
+          </p:cNvPr>
+          <p:cNvSpPr>
+            <a:spLocks noGrp="1"/>
+          </p:cNvSpPr>
+          <p:nvPr>
+            <p:ph type="sldNum" sz="quarter" idx="4"/>
+          </p:nvPr>
+        </p:nvSpPr>
+        <p:spPr/>
+        <p:txBody>
+          <a:bodyPr/>
+          <a:lstStyle/>
+          <a:p>
+            <a:fld id="{33C783E2-4793-4F48-A271-51A73CC37D74}" type="slidenum">
+              <a:rPr lang="fr-FR" smtClean="0"/>
+              <a:t>37</a:t>
+            </a:fld>
+            <a:endParaRPr lang="fr-FR"/>
+          </a:p>
+        </p:txBody>
+      </p:sp>
+      <p:sp>
+        <p:nvSpPr>
+          <p:cNvPr id="18" name="Repere de section"/>
+          <p:cNvSpPr txBox="1"/>
+          <p:nvPr/>
+        </p:nvSpPr>
+        <p:spPr>
+          <a:xfrm>
+            <a:off x="6583680" y="6382512"/>
+            <a:ext cx="4480560" cy="320040"/>
+          </a:xfrm>
+          <a:prstGeom prst="rect">
+            <a:avLst/>
+          </a:prstGeom>
+          <a:noFill/>
+        </p:spPr>
+        <p:txBody>
+          <a:bodyPr wrap="none" tIns="0" bIns="0">
+            <a:spAutoFit/>
+          </a:bodyPr>
+          <a:lstStyle/>
+          <a:p>
+            <a:pPr algn="r"/>
+            <a:r>
+              <a:rPr sz="1100">
+                <a:solidFill>
+                  <a:srgbClr val="BCBEC4"/>
+                </a:solidFill>
+              </a:rPr>
+              <a:t>ABS · </a:t>
+            </a:r>
+            <a:r>
+              <a:rPr sz="1100" b="1">
+                <a:solidFill>
+                  <a:schemeClr val="accent4"/>
+                </a:solidFill>
+              </a:rPr>
+              <a:t>6. La mère appelle la fille</a:t>
+            </a:r>
+          </a:p>
+        </p:txBody>
+      </p:sp>
+    </p:spTree>
+  </p:cSld>
+  <p:clrMapOvr>
+    <a:masterClrMapping/>
+  </p:clrMapOvr>
+</p:sld>
+</file>
+
+<file path=ppt/slides/slide39.xml><?xml version="1.0" encoding="utf-8"?>
 <p:sld xmlns:a="http://schemas.openxmlformats.org/drawingml/2006/main" xmlns:r="http://schemas.openxmlformats.org/officeDocument/2006/relationships" xmlns:p="http://schemas.openxmlformats.org/presentationml/2006/main">
   <p:cSld>
     <p:spTree>
@@ -25600,167 +25871,6 @@
               </a:rPr>
               <a:t>6. La mère appelle la fille</a:t>
             </a:r>
-          </a:p>
-        </p:txBody>
-      </p:sp>
-    </p:spTree>
-  </p:cSld>
-  <p:clrMapOvr>
-    <a:masterClrMapping/>
-  </p:clrMapOvr>
-</p:sld>
-</file>
-
-<file path=ppt/slides/slide39.xml><?xml version="1.0" encoding="utf-8"?>
-<p:sld xmlns:a="http://schemas.openxmlformats.org/drawingml/2006/main" xmlns:r="http://schemas.openxmlformats.org/officeDocument/2006/relationships" xmlns:p="http://schemas.openxmlformats.org/presentationml/2006/main">
-  <p:cSld>
-    <p:spTree>
-      <p:nvGrpSpPr>
-        <p:cNvPr id="1" name=""/>
-        <p:cNvGrpSpPr/>
-        <p:nvPr/>
-      </p:nvGrpSpPr>
-      <p:grpSpPr>
-        <a:xfrm>
-          <a:off x="0" y="0"/>
-          <a:ext cx="0" cy="0"/>
-          <a:chOff x="0" y="0"/>
-          <a:chExt cx="0" cy="0"/>
-        </a:xfrm>
-      </p:grpSpPr>
-      <p:pic>
-        <p:nvPicPr>
-          <p:cNvPr id="3" name="Image 2" descr="A futuristic digital illustration in deep blue tones, isometric view, on a dark circuit board. Three floating platforms of light are stacked vertically, connected by glowing beams. On the top platform: a faint, ghostly, transparent wireframe outline of a generic vehicle, made only of thin glowing lines, with many empty glowing sockets where parts are missing. On the middle platform: the same vehicle outline, now half-solid and semi-transparent, with wings filled in as solid glowing parts, but a few sockets still empty, especially the engine. On the bottom platform: a fully solid, complete, luminous flying drone, all sockets filled, bright and real. The same base silhouette is clearly recognizable on all three levels. A sense of progressive materialization from top to bottom. Glowing particles, cinematic lighting, photorealistic, no text.">
-            <a:extLst>
-              <a:ext uri="{FF2B5EF4-FFF2-40B4-BE49-F238E27FC236}">
-                <a16:creationId xmlns:a16="http://schemas.microsoft.com/office/drawing/2014/main" id="{51AEABB8-4A4F-9F02-561B-870B390F8D16}"/>
-              </a:ext>
-            </a:extLst>
-          </p:cNvPr>
-          <p:cNvPicPr>
-            <a:picLocks noChangeAspect="1"/>
-          </p:cNvPicPr>
-          <p:nvPr/>
-        </p:nvPicPr>
-        <p:blipFill>
-          <a:blip r:embed="rId3" cstate="print">
-            <a:extLst>
-              <a:ext uri="{28A0092B-C50C-407E-A947-70E740481C1C}">
-                <a14:useLocalDpi xmlns:a14="http://schemas.microsoft.com/office/drawing/2010/main"/>
-              </a:ext>
-            </a:extLst>
-          </a:blip>
-          <a:srcRect/>
-          <a:stretch>
-            <a:fillRect/>
-          </a:stretch>
-        </p:blipFill>
-        <p:spPr>
-          <a:xfrm>
-            <a:off x="1" y="1"/>
-            <a:ext cx="12231975" cy="6955432"/>
-          </a:xfrm>
-          <a:prstGeom prst="rect">
-            <a:avLst/>
-          </a:prstGeom>
-        </p:spPr>
-      </p:pic>
-      <p:sp>
-        <p:nvSpPr>
-          <p:cNvPr id="2" name="ZoneTexte 1">
-            <a:extLst>
-              <a:ext uri="{FF2B5EF4-FFF2-40B4-BE49-F238E27FC236}">
-                <a16:creationId xmlns:a16="http://schemas.microsoft.com/office/drawing/2014/main" id="{1233F0E3-E637-79C1-4DA0-C29FF4C8620E}"/>
-              </a:ext>
-            </a:extLst>
-          </p:cNvPr>
-          <p:cNvSpPr txBox="1"/>
-          <p:nvPr/>
-        </p:nvSpPr>
-        <p:spPr>
-          <a:xfrm>
-            <a:off x="838200" y="946800"/>
-            <a:ext cx="5344500" cy="1105200"/>
-          </a:xfrm>
-          <a:prstGeom prst="rect">
-            <a:avLst/>
-          </a:prstGeom>
-          <a:solidFill>
-            <a:schemeClr val="bg2">
-              <a:lumMod val="50000"/>
-              <a:alpha val="74902"/>
-            </a:schemeClr>
-          </a:solidFill>
-          <a:effectLst>
-            <a:outerShdw blurRad="50800" dist="38100" dir="2700000" algn="tl" rotWithShape="0">
-              <a:prstClr val="black">
-                <a:alpha val="40000"/>
-              </a:prstClr>
-            </a:outerShdw>
-          </a:effectLst>
-        </p:spPr>
-        <p:txBody>
-          <a:bodyPr wrap="square" rtlCol="0">
-            <a:spAutoFit/>
-          </a:bodyPr>
-          <a:lstStyle/>
-          <a:p>
-            <a:r>
-              <a:rPr lang="fr-FR" sz="6600" b="1" dirty="0">
-                <a:ln w="0"/>
-                <a:effectLst>
-                  <a:outerShdw blurRad="38100" dist="19050" dir="2700000" algn="tl" rotWithShape="0">
-                    <a:schemeClr val="dk1">
-                      <a:alpha val="40000"/>
-                    </a:schemeClr>
-                  </a:outerShdw>
-                </a:effectLst>
-                <a:latin typeface="Calibri"/>
-                <a:cs typeface="Calibri"/>
-              </a:rPr>
-              <a:t>7. Deux étages</a:t>
-            </a:r>
-            <a:endParaRPr lang="fr-FR" sz="1600" b="1" dirty="0">
-              <a:ln w="0"/>
-              <a:effectLst>
-                <a:outerShdw blurRad="38100" dist="19050" dir="2700000" algn="tl" rotWithShape="0">
-                  <a:schemeClr val="dk1">
-                    <a:alpha val="40000"/>
-                  </a:schemeClr>
-                </a:outerShdw>
-              </a:effectLst>
-              <a:latin typeface="Calibri" panose="020F0502020204030204" pitchFamily="34" charset="0"/>
-              <a:cs typeface="Calibri" panose="020F0502020204030204" pitchFamily="34" charset="0"/>
-            </a:endParaRPr>
-          </a:p>
-        </p:txBody>
-      </p:sp>
-      <p:sp>
-        <p:nvSpPr>
-          <p:cNvPr id="4" name="Espace réservé du numéro de diapositive 3">
-            <a:extLst>
-              <a:ext uri="{FF2B5EF4-FFF2-40B4-BE49-F238E27FC236}">
-                <a16:creationId xmlns:a16="http://schemas.microsoft.com/office/drawing/2014/main" id="{461DFEF1-FAFC-ECE7-F556-CD1C796960AF}"/>
-              </a:ext>
-            </a:extLst>
-          </p:cNvPr>
-          <p:cNvSpPr>
-            <a:spLocks noGrp="1"/>
-          </p:cNvSpPr>
-          <p:nvPr>
-            <p:ph type="sldNum" sz="quarter" idx="4"/>
-          </p:nvPr>
-        </p:nvSpPr>
-        <p:spPr/>
-        <p:txBody>
-          <a:bodyPr/>
-          <a:lstStyle/>
-          <a:p>
-            <a:fld id="{33C783E2-4793-4F48-A271-51A73CC37D74}" type="slidenum">
-              <a:rPr lang="fr-FR" smtClean="0"/>
-              <a:t>39</a:t>
-            </a:fld>
-            <a:endParaRPr lang="fr-FR"/>
           </a:p>
         </p:txBody>
       </p:sp>
@@ -26462,6 +26572,167 @@
           <a:chExt cx="0" cy="0"/>
         </a:xfrm>
       </p:grpSpPr>
+      <p:pic>
+        <p:nvPicPr>
+          <p:cNvPr id="3" name="Image 2" descr="A futuristic digital illustration in deep blue tones, isometric view, on a dark circuit board. Three floating platforms of light are stacked vertically, connected by glowing beams. On the top platform: a faint, ghostly, transparent wireframe outline of a generic vehicle, made only of thin glowing lines, with many empty glowing sockets where parts are missing. On the middle platform: the same vehicle outline, now half-solid and semi-transparent, with wings filled in as solid glowing parts, but a few sockets still empty, especially the engine. On the bottom platform: a fully solid, complete, luminous flying drone, all sockets filled, bright and real. The same base silhouette is clearly recognizable on all three levels. A sense of progressive materialization from top to bottom. Glowing particles, cinematic lighting, photorealistic, no text.">
+            <a:extLst>
+              <a:ext uri="{FF2B5EF4-FFF2-40B4-BE49-F238E27FC236}">
+                <a16:creationId xmlns:a16="http://schemas.microsoft.com/office/drawing/2014/main" id="{51AEABB8-4A4F-9F02-561B-870B390F8D16}"/>
+              </a:ext>
+            </a:extLst>
+          </p:cNvPr>
+          <p:cNvPicPr>
+            <a:picLocks noChangeAspect="1"/>
+          </p:cNvPicPr>
+          <p:nvPr/>
+        </p:nvPicPr>
+        <p:blipFill>
+          <a:blip r:embed="rId3" cstate="print">
+            <a:extLst>
+              <a:ext uri="{28A0092B-C50C-407E-A947-70E740481C1C}">
+                <a14:useLocalDpi xmlns:a14="http://schemas.microsoft.com/office/drawing/2010/main"/>
+              </a:ext>
+            </a:extLst>
+          </a:blip>
+          <a:srcRect/>
+          <a:stretch>
+            <a:fillRect/>
+          </a:stretch>
+        </p:blipFill>
+        <p:spPr>
+          <a:xfrm>
+            <a:off x="1" y="1"/>
+            <a:ext cx="12231975" cy="6955432"/>
+          </a:xfrm>
+          <a:prstGeom prst="rect">
+            <a:avLst/>
+          </a:prstGeom>
+        </p:spPr>
+      </p:pic>
+      <p:sp>
+        <p:nvSpPr>
+          <p:cNvPr id="2" name="ZoneTexte 1">
+            <a:extLst>
+              <a:ext uri="{FF2B5EF4-FFF2-40B4-BE49-F238E27FC236}">
+                <a16:creationId xmlns:a16="http://schemas.microsoft.com/office/drawing/2014/main" id="{1233F0E3-E637-79C1-4DA0-C29FF4C8620E}"/>
+              </a:ext>
+            </a:extLst>
+          </p:cNvPr>
+          <p:cNvSpPr txBox="1"/>
+          <p:nvPr/>
+        </p:nvSpPr>
+        <p:spPr>
+          <a:xfrm>
+            <a:off x="838200" y="946800"/>
+            <a:ext cx="5344500" cy="1105200"/>
+          </a:xfrm>
+          <a:prstGeom prst="rect">
+            <a:avLst/>
+          </a:prstGeom>
+          <a:solidFill>
+            <a:schemeClr val="bg2">
+              <a:lumMod val="50000"/>
+              <a:alpha val="74902"/>
+            </a:schemeClr>
+          </a:solidFill>
+          <a:effectLst>
+            <a:outerShdw blurRad="50800" dist="38100" dir="2700000" algn="tl" rotWithShape="0">
+              <a:prstClr val="black">
+                <a:alpha val="40000"/>
+              </a:prstClr>
+            </a:outerShdw>
+          </a:effectLst>
+        </p:spPr>
+        <p:txBody>
+          <a:bodyPr wrap="square" rtlCol="0">
+            <a:spAutoFit/>
+          </a:bodyPr>
+          <a:lstStyle/>
+          <a:p>
+            <a:r>
+              <a:rPr lang="fr-FR" sz="6600" b="1" dirty="0">
+                <a:ln w="0"/>
+                <a:effectLst>
+                  <a:outerShdw blurRad="38100" dist="19050" dir="2700000" algn="tl" rotWithShape="0">
+                    <a:schemeClr val="dk1">
+                      <a:alpha val="40000"/>
+                    </a:schemeClr>
+                  </a:outerShdw>
+                </a:effectLst>
+                <a:latin typeface="Calibri"/>
+                <a:cs typeface="Calibri"/>
+              </a:rPr>
+              <a:t>7. Deux étages</a:t>
+            </a:r>
+            <a:endParaRPr lang="fr-FR" sz="1600" b="1" dirty="0">
+              <a:ln w="0"/>
+              <a:effectLst>
+                <a:outerShdw blurRad="38100" dist="19050" dir="2700000" algn="tl" rotWithShape="0">
+                  <a:schemeClr val="dk1">
+                    <a:alpha val="40000"/>
+                  </a:schemeClr>
+                </a:outerShdw>
+              </a:effectLst>
+              <a:latin typeface="Calibri" panose="020F0502020204030204" pitchFamily="34" charset="0"/>
+              <a:cs typeface="Calibri" panose="020F0502020204030204" pitchFamily="34" charset="0"/>
+            </a:endParaRPr>
+          </a:p>
+        </p:txBody>
+      </p:sp>
+      <p:sp>
+        <p:nvSpPr>
+          <p:cNvPr id="4" name="Espace réservé du numéro de diapositive 3">
+            <a:extLst>
+              <a:ext uri="{FF2B5EF4-FFF2-40B4-BE49-F238E27FC236}">
+                <a16:creationId xmlns:a16="http://schemas.microsoft.com/office/drawing/2014/main" id="{461DFEF1-FAFC-ECE7-F556-CD1C796960AF}"/>
+              </a:ext>
+            </a:extLst>
+          </p:cNvPr>
+          <p:cNvSpPr>
+            <a:spLocks noGrp="1"/>
+          </p:cNvSpPr>
+          <p:nvPr>
+            <p:ph type="sldNum" sz="quarter" idx="4"/>
+          </p:nvPr>
+        </p:nvSpPr>
+        <p:spPr/>
+        <p:txBody>
+          <a:bodyPr/>
+          <a:lstStyle/>
+          <a:p>
+            <a:fld id="{33C783E2-4793-4F48-A271-51A73CC37D74}" type="slidenum">
+              <a:rPr lang="fr-FR" smtClean="0"/>
+              <a:t>39</a:t>
+            </a:fld>
+            <a:endParaRPr lang="fr-FR"/>
+          </a:p>
+        </p:txBody>
+      </p:sp>
+    </p:spTree>
+  </p:cSld>
+  <p:clrMapOvr>
+    <a:masterClrMapping/>
+  </p:clrMapOvr>
+</p:sld>
+</file>
+
+<file path=ppt/slides/slide41.xml><?xml version="1.0" encoding="utf-8"?>
+<p:sld xmlns:a="http://schemas.openxmlformats.org/drawingml/2006/main" xmlns:r="http://schemas.openxmlformats.org/officeDocument/2006/relationships" xmlns:p="http://schemas.openxmlformats.org/presentationml/2006/main">
+  <p:cSld>
+    <p:spTree>
+      <p:nvGrpSpPr>
+        <p:cNvPr id="1" name=""/>
+        <p:cNvGrpSpPr/>
+        <p:nvPr/>
+      </p:nvGrpSpPr>
+      <p:grpSpPr>
+        <a:xfrm>
+          <a:off x="0" y="0"/>
+          <a:ext cx="0" cy="0"/>
+          <a:chOff x="0" y="0"/>
+          <a:chExt cx="0" cy="0"/>
+        </a:xfrm>
+      </p:grpSpPr>
       <p:sp>
         <p:nvSpPr>
           <p:cNvPr id="2" name="Title 1"/>
@@ -26913,742 +27184,6 @@
             <a:fld id="{33C783E2-4793-4F48-A271-51A73CC37D74}" type="slidenum">
               <a:rPr lang="fr-FR" smtClean="0"/>
               <a:t>40</a:t>
-            </a:fld>
-            <a:endParaRPr lang="fr-FR"/>
-          </a:p>
-        </p:txBody>
-      </p:sp>
-      <p:sp>
-        <p:nvSpPr>
-          <p:cNvPr id="18" name="Repere de section"/>
-          <p:cNvSpPr txBox="1"/>
-          <p:nvPr/>
-        </p:nvSpPr>
-        <p:spPr>
-          <a:xfrm>
-            <a:off x="6583680" y="6382512"/>
-            <a:ext cx="4480560" cy="320040"/>
-          </a:xfrm>
-          <a:prstGeom prst="rect">
-            <a:avLst/>
-          </a:prstGeom>
-          <a:noFill/>
-        </p:spPr>
-        <p:txBody>
-          <a:bodyPr wrap="none" tIns="0" bIns="0">
-            <a:spAutoFit/>
-          </a:bodyPr>
-          <a:lstStyle/>
-          <a:p>
-            <a:pPr algn="r"/>
-            <a:r>
-              <a:rPr sz="1100">
-                <a:solidFill>
-                  <a:srgbClr val="BCBEC4"/>
-                </a:solidFill>
-              </a:rPr>
-              <a:t>ABS · </a:t>
-            </a:r>
-            <a:r>
-              <a:rPr sz="1100" b="1">
-                <a:solidFill>
-                  <a:schemeClr val="accent4"/>
-                </a:solidFill>
-              </a:rPr>
-              <a:t>7. Deux étages</a:t>
-            </a:r>
-          </a:p>
-        </p:txBody>
-      </p:sp>
-    </p:spTree>
-  </p:cSld>
-  <p:clrMapOvr>
-    <a:masterClrMapping/>
-  </p:clrMapOvr>
-  <p:timing>
-    <p:tnLst>
-      <p:par>
-        <p:cTn id="1" dur="indefinite" restart="never" nodeType="tmRoot">
-          <p:childTnLst>
-            <p:seq concurrent="1" nextAc="seek">
-              <p:cTn id="2" dur="indefinite" nodeType="mainSeq">
-                <p:childTnLst>
-                  <p:par>
-                    <p:cTn id="3" fill="hold">
-                      <p:stCondLst>
-                        <p:cond delay="indefinite"/>
-                      </p:stCondLst>
-                      <p:childTnLst>
-                        <p:par>
-                          <p:cTn id="4" fill="hold">
-                            <p:stCondLst>
-                              <p:cond delay="0"/>
-                            </p:stCondLst>
-                            <p:childTnLst>
-                              <p:par>
-                                <p:cTn id="5" presetID="10" presetClass="entr" presetSubtype="0" fill="hold" grpId="0" nodeType="clickEffect">
-                                  <p:stCondLst>
-                                    <p:cond delay="0"/>
-                                  </p:stCondLst>
-                                  <p:childTnLst>
-                                    <p:set>
-                                      <p:cBhvr>
-                                        <p:cTn id="6" dur="1" fill="hold">
-                                          <p:stCondLst>
-                                            <p:cond delay="0"/>
-                                          </p:stCondLst>
-                                        </p:cTn>
-                                        <p:tgtEl>
-                                          <p:spTgt spid="4"/>
-                                        </p:tgtEl>
-                                        <p:attrNameLst>
-                                          <p:attrName>style.visibility</p:attrName>
-                                        </p:attrNameLst>
-                                      </p:cBhvr>
-                                      <p:to>
-                                        <p:strVal val="visible"/>
-                                      </p:to>
-                                    </p:set>
-                                    <p:animEffect transition="in" filter="fade">
-                                      <p:cBhvr>
-                                        <p:cTn id="7" dur="500"/>
-                                        <p:tgtEl>
-                                          <p:spTgt spid="4"/>
-                                        </p:tgtEl>
-                                      </p:cBhvr>
-                                    </p:animEffect>
-                                  </p:childTnLst>
-                                </p:cTn>
-                              </p:par>
-                            </p:childTnLst>
-                          </p:cTn>
-                        </p:par>
-                      </p:childTnLst>
-                    </p:cTn>
-                  </p:par>
-                </p:childTnLst>
-              </p:cTn>
-              <p:prevCondLst>
-                <p:cond evt="onPrev" delay="0">
-                  <p:tgtEl>
-                    <p:sldTgt/>
-                  </p:tgtEl>
-                </p:cond>
-              </p:prevCondLst>
-              <p:nextCondLst>
-                <p:cond evt="onNext" delay="0">
-                  <p:tgtEl>
-                    <p:sldTgt/>
-                  </p:tgtEl>
-                </p:cond>
-              </p:nextCondLst>
-            </p:seq>
-          </p:childTnLst>
-        </p:cTn>
-      </p:par>
-    </p:tnLst>
-    <p:bldLst>
-      <p:bldP spid="4" grpId="0" animBg="1"/>
-    </p:bldLst>
-  </p:timing>
-</p:sld>
-</file>
-
-<file path=ppt/slides/slide41.xml><?xml version="1.0" encoding="utf-8"?>
-<p:sld xmlns:a="http://schemas.openxmlformats.org/drawingml/2006/main" xmlns:r="http://schemas.openxmlformats.org/officeDocument/2006/relationships" xmlns:p="http://schemas.openxmlformats.org/presentationml/2006/main">
-  <p:cSld>
-    <p:spTree>
-      <p:nvGrpSpPr>
-        <p:cNvPr id="1" name=""/>
-        <p:cNvGrpSpPr/>
-        <p:nvPr/>
-      </p:nvGrpSpPr>
-      <p:grpSpPr>
-        <a:xfrm>
-          <a:off x="0" y="0"/>
-          <a:ext cx="0" cy="0"/>
-          <a:chOff x="0" y="0"/>
-          <a:chExt cx="0" cy="0"/>
-        </a:xfrm>
-      </p:grpSpPr>
-      <p:sp>
-        <p:nvSpPr>
-          <p:cNvPr id="2" name="Title 1"/>
-          <p:cNvSpPr>
-            <a:spLocks noGrp="1"/>
-          </p:cNvSpPr>
-          <p:nvPr>
-            <p:ph type="title"/>
-          </p:nvPr>
-        </p:nvSpPr>
-        <p:spPr/>
-        <p:txBody>
-          <a:bodyPr>
-            <a:noAutofit/>
-          </a:bodyPr>
-          <a:lstStyle/>
-          <a:p>
-            <a:r>
-              <a:rPr sz="4000"/>
-              <a:t>Où placer chaque champ</a:t>
-            </a:r>
-          </a:p>
-        </p:txBody>
-      </p:sp>
-      <p:sp>
-        <p:nvSpPr>
-          <p:cNvPr id="3" name="Content Placeholder 2"/>
-          <p:cNvSpPr>
-            <a:spLocks noGrp="1"/>
-          </p:cNvSpPr>
-          <p:nvPr>
-            <p:ph idx="1"/>
-          </p:nvPr>
-        </p:nvSpPr>
-        <p:spPr>
-          <a:xfrm>
-            <a:off x="640080" y="1371600"/>
-            <a:ext cx="10881360" cy="1798320"/>
-          </a:xfrm>
-        </p:spPr>
-        <p:txBody>
-          <a:bodyPr/>
-          <a:lstStyle/>
-          <a:p>
-            <a:pPr marL="0" indent="0">
-              <a:spcAft>
-                <a:spcPts val="1000"/>
-              </a:spcAft>
-              <a:buNone/>
-            </a:pPr>
-            <a:r>
-              <a:rPr sz="2800"/>
-              <a:t>Un champ se déclare à l'étage où il devient commun</a:t>
-            </a:r>
-          </a:p>
-          <a:p>
-            <a:pPr marL="0" indent="0">
-              <a:spcAft>
-                <a:spcPts val="1000"/>
-              </a:spcAft>
-              <a:buNone/>
-            </a:pPr>
-            <a:r>
-              <a:rPr sz="2800"/>
-              <a:t>Trop haut, il encombre qui n'en a pas l'usage</a:t>
-            </a:r>
-          </a:p>
-          <a:p>
-            <a:pPr marL="0" indent="0">
-              <a:spcAft>
-                <a:spcPts val="1000"/>
-              </a:spcAft>
-              <a:buNone/>
-            </a:pPr>
-            <a:r>
-              <a:rPr sz="2800"/>
-              <a:t>Trop bas, il s'écrit deux fois</a:t>
-            </a:r>
-          </a:p>
-        </p:txBody>
-      </p:sp>
-      <p:sp>
-        <p:nvSpPr>
-          <p:cNvPr id="4" name="Code"/>
-          <p:cNvSpPr txBox="1"/>
-          <p:nvPr/>
-        </p:nvSpPr>
-        <p:spPr>
-          <a:xfrm>
-            <a:off x="2451100" y="3307080"/>
-            <a:ext cx="7289800" cy="2743200"/>
-          </a:xfrm>
-          <a:prstGeom prst="roundRect">
-            <a:avLst>
-              <a:gd name="adj" fmla="val 3333"/>
-            </a:avLst>
-          </a:prstGeom>
-          <a:solidFill>
-            <a:srgbClr val="1D1F22"/>
-          </a:solidFill>
-          <a:effectLst>
-            <a:outerShdw blurRad="50800" dist="38100" dir="2700000" algn="tl" rotWithShape="0">
-              <a:prstClr val="black">
-                <a:alpha val="40000"/>
-              </a:prstClr>
-            </a:outerShdw>
-          </a:effectLst>
-        </p:spPr>
-        <p:txBody>
-          <a:bodyPr wrap="none" lIns="137160" tIns="91440" rIns="137160" bIns="91440"/>
-          <a:lstStyle/>
-          <a:p>
-            <a:pPr>
-              <a:lnSpc>
-                <a:spcPct val="100000"/>
-              </a:lnSpc>
-              <a:spcBef>
-                <a:spcPts val="0"/>
-              </a:spcBef>
-              <a:spcAft>
-                <a:spcPts val="0"/>
-              </a:spcAft>
-            </a:pPr>
-            <a:r>
-              <a:rPr sz="1800">
-                <a:solidFill>
-                  <a:srgbClr val="CF8E6D"/>
-                </a:solidFill>
-                <a:latin typeface="Consolas"/>
-              </a:rPr>
-              <a:t>public</a:t>
-            </a:r>
-            <a:r>
-              <a:rPr sz="1800">
-                <a:solidFill>
-                  <a:srgbClr val="BCBEC4"/>
-                </a:solidFill>
-                <a:latin typeface="Consolas"/>
-              </a:rPr>
-              <a:t> </a:t>
-            </a:r>
-            <a:r>
-              <a:rPr sz="1800">
-                <a:solidFill>
-                  <a:srgbClr val="CF8E6D"/>
-                </a:solidFill>
-                <a:latin typeface="Consolas"/>
-              </a:rPr>
-              <a:t>abstract</a:t>
-            </a:r>
-            <a:r>
-              <a:rPr sz="1800">
-                <a:solidFill>
-                  <a:srgbClr val="BCBEC4"/>
-                </a:solidFill>
-                <a:latin typeface="Consolas"/>
-              </a:rPr>
-              <a:t> </a:t>
-            </a:r>
-            <a:r>
-              <a:rPr sz="1800">
-                <a:solidFill>
-                  <a:srgbClr val="CF8E6D"/>
-                </a:solidFill>
-                <a:latin typeface="Consolas"/>
-              </a:rPr>
-              <a:t>class</a:t>
-            </a:r>
-            <a:r>
-              <a:rPr sz="1800">
-                <a:solidFill>
-                  <a:srgbClr val="BCBEC4"/>
-                </a:solidFill>
-                <a:latin typeface="Consolas"/>
-              </a:rPr>
-              <a:t> Horaire </a:t>
-            </a:r>
-            <a:r>
-              <a:rPr sz="1800">
-                <a:solidFill>
-                  <a:srgbClr val="CF8E6D"/>
-                </a:solidFill>
-                <a:latin typeface="Consolas"/>
-              </a:rPr>
-              <a:t>extends</a:t>
-            </a:r>
-            <a:r>
-              <a:rPr sz="1800">
-                <a:solidFill>
-                  <a:srgbClr val="BCBEC4"/>
-                </a:solidFill>
-                <a:latin typeface="Consolas"/>
-              </a:rPr>
-              <a:t> Prestation {</a:t>
-            </a:r>
-          </a:p>
-          <a:p>
-            <a:pPr>
-              <a:lnSpc>
-                <a:spcPct val="100000"/>
-              </a:lnSpc>
-              <a:spcBef>
-                <a:spcPts val="0"/>
-              </a:spcBef>
-              <a:spcAft>
-                <a:spcPts val="0"/>
-              </a:spcAft>
-            </a:pPr>
-            <a:r>
-              <a:rPr sz="1800">
-                <a:solidFill>
-                  <a:srgbClr val="BCBEC4"/>
-                </a:solidFill>
-                <a:latin typeface="Consolas"/>
-              </a:rPr>
-              <a:t> </a:t>
-            </a:r>
-          </a:p>
-          <a:p>
-            <a:pPr>
-              <a:lnSpc>
-                <a:spcPct val="100000"/>
-              </a:lnSpc>
-              <a:spcBef>
-                <a:spcPts val="0"/>
-              </a:spcBef>
-              <a:spcAft>
-                <a:spcPts val="0"/>
-              </a:spcAft>
-            </a:pPr>
-            <a:r>
-              <a:rPr sz="1800">
-                <a:solidFill>
-                  <a:srgbClr val="BCBEC4"/>
-                </a:solidFill>
-                <a:latin typeface="Consolas"/>
-              </a:rPr>
-              <a:t>    </a:t>
-            </a:r>
-            <a:r>
-              <a:rPr sz="1800">
-                <a:solidFill>
-                  <a:srgbClr val="CF8E6D"/>
-                </a:solidFill>
-                <a:latin typeface="Consolas"/>
-              </a:rPr>
-              <a:t>private</a:t>
-            </a:r>
-            <a:r>
-              <a:rPr sz="1800">
-                <a:solidFill>
-                  <a:srgbClr val="BCBEC4"/>
-                </a:solidFill>
-                <a:latin typeface="Consolas"/>
-              </a:rPr>
-              <a:t> </a:t>
-            </a:r>
-            <a:r>
-              <a:rPr sz="1800">
-                <a:solidFill>
-                  <a:srgbClr val="CF8E6D"/>
-                </a:solidFill>
-                <a:latin typeface="Consolas"/>
-              </a:rPr>
-              <a:t>final</a:t>
-            </a:r>
-            <a:r>
-              <a:rPr sz="1800">
-                <a:solidFill>
-                  <a:srgbClr val="BCBEC4"/>
-                </a:solidFill>
-                <a:latin typeface="Consolas"/>
-              </a:rPr>
-              <a:t> </a:t>
-            </a:r>
-            <a:r>
-              <a:rPr sz="1800">
-                <a:solidFill>
-                  <a:srgbClr val="CF8E6D"/>
-                </a:solidFill>
-                <a:latin typeface="Consolas"/>
-              </a:rPr>
-              <a:t>double</a:t>
-            </a:r>
-            <a:r>
-              <a:rPr sz="1800">
-                <a:solidFill>
-                  <a:srgbClr val="BCBEC4"/>
-                </a:solidFill>
-                <a:latin typeface="Consolas"/>
-              </a:rPr>
-              <a:t> tauxHoraire;</a:t>
-            </a:r>
-          </a:p>
-          <a:p>
-            <a:pPr>
-              <a:lnSpc>
-                <a:spcPct val="100000"/>
-              </a:lnSpc>
-              <a:spcBef>
-                <a:spcPts val="0"/>
-              </a:spcBef>
-              <a:spcAft>
-                <a:spcPts val="0"/>
-              </a:spcAft>
-            </a:pPr>
-            <a:r>
-              <a:rPr sz="1800">
-                <a:solidFill>
-                  <a:srgbClr val="BCBEC4"/>
-                </a:solidFill>
-                <a:latin typeface="Consolas"/>
-              </a:rPr>
-              <a:t>    </a:t>
-            </a:r>
-            <a:r>
-              <a:rPr sz="1800">
-                <a:solidFill>
-                  <a:srgbClr val="CF8E6D"/>
-                </a:solidFill>
-                <a:latin typeface="Consolas"/>
-              </a:rPr>
-              <a:t>private</a:t>
-            </a:r>
-            <a:r>
-              <a:rPr sz="1800">
-                <a:solidFill>
-                  <a:srgbClr val="BCBEC4"/>
-                </a:solidFill>
-                <a:latin typeface="Consolas"/>
-              </a:rPr>
-              <a:t> </a:t>
-            </a:r>
-            <a:r>
-              <a:rPr sz="1800">
-                <a:solidFill>
-                  <a:srgbClr val="CF8E6D"/>
-                </a:solidFill>
-                <a:latin typeface="Consolas"/>
-              </a:rPr>
-              <a:t>final</a:t>
-            </a:r>
-            <a:r>
-              <a:rPr sz="1800">
-                <a:solidFill>
-                  <a:srgbClr val="BCBEC4"/>
-                </a:solidFill>
-                <a:latin typeface="Consolas"/>
-              </a:rPr>
-              <a:t> </a:t>
-            </a:r>
-            <a:r>
-              <a:rPr sz="1800">
-                <a:solidFill>
-                  <a:srgbClr val="CF8E6D"/>
-                </a:solidFill>
-                <a:latin typeface="Consolas"/>
-              </a:rPr>
-              <a:t>int</a:t>
-            </a:r>
-            <a:r>
-              <a:rPr sz="1800">
-                <a:solidFill>
-                  <a:srgbClr val="BCBEC4"/>
-                </a:solidFill>
-                <a:latin typeface="Consolas"/>
-              </a:rPr>
-              <a:t> heures;</a:t>
-            </a:r>
-          </a:p>
-          <a:p>
-            <a:pPr>
-              <a:lnSpc>
-                <a:spcPct val="100000"/>
-              </a:lnSpc>
-              <a:spcBef>
-                <a:spcPts val="0"/>
-              </a:spcBef>
-              <a:spcAft>
-                <a:spcPts val="0"/>
-              </a:spcAft>
-            </a:pPr>
-            <a:r>
-              <a:rPr sz="1800">
-                <a:solidFill>
-                  <a:srgbClr val="BCBEC4"/>
-                </a:solidFill>
-                <a:latin typeface="Consolas"/>
-              </a:rPr>
-              <a:t> </a:t>
-            </a:r>
-          </a:p>
-          <a:p>
-            <a:pPr>
-              <a:lnSpc>
-                <a:spcPct val="100000"/>
-              </a:lnSpc>
-              <a:spcBef>
-                <a:spcPts val="0"/>
-              </a:spcBef>
-              <a:spcAft>
-                <a:spcPts val="0"/>
-              </a:spcAft>
-            </a:pPr>
-            <a:r>
-              <a:rPr sz="1800">
-                <a:solidFill>
-                  <a:srgbClr val="BCBEC4"/>
-                </a:solidFill>
-                <a:latin typeface="Consolas"/>
-              </a:rPr>
-              <a:t>    </a:t>
-            </a:r>
-            <a:r>
-              <a:rPr sz="1800">
-                <a:solidFill>
-                  <a:srgbClr val="CF8E6D"/>
-                </a:solidFill>
-                <a:latin typeface="Consolas"/>
-              </a:rPr>
-              <a:t>protected</a:t>
-            </a:r>
-            <a:r>
-              <a:rPr sz="1800">
-                <a:solidFill>
-                  <a:srgbClr val="BCBEC4"/>
-                </a:solidFill>
-                <a:latin typeface="Consolas"/>
-              </a:rPr>
-              <a:t> </a:t>
-            </a:r>
-            <a:r>
-              <a:rPr sz="1800">
-                <a:solidFill>
-                  <a:srgbClr val="CF8E6D"/>
-                </a:solidFill>
-                <a:latin typeface="Consolas"/>
-              </a:rPr>
-              <a:t>double</a:t>
-            </a:r>
-            <a:r>
-              <a:rPr sz="1800">
-                <a:solidFill>
-                  <a:srgbClr val="BCBEC4"/>
-                </a:solidFill>
-                <a:latin typeface="Consolas"/>
-              </a:rPr>
-              <a:t> </a:t>
-            </a:r>
-            <a:r>
-              <a:rPr sz="1800">
-                <a:solidFill>
-                  <a:srgbClr val="56A8F5"/>
-                </a:solidFill>
-                <a:latin typeface="Consolas"/>
-              </a:rPr>
-              <a:t>base</a:t>
-            </a:r>
-            <a:r>
-              <a:rPr sz="1800">
-                <a:solidFill>
-                  <a:srgbClr val="BCBEC4"/>
-                </a:solidFill>
-                <a:latin typeface="Consolas"/>
-              </a:rPr>
-              <a:t>() {</a:t>
-            </a:r>
-          </a:p>
-          <a:p>
-            <a:pPr>
-              <a:lnSpc>
-                <a:spcPct val="100000"/>
-              </a:lnSpc>
-              <a:spcBef>
-                <a:spcPts val="0"/>
-              </a:spcBef>
-              <a:spcAft>
-                <a:spcPts val="0"/>
-              </a:spcAft>
-            </a:pPr>
-            <a:r>
-              <a:rPr sz="1800">
-                <a:solidFill>
-                  <a:srgbClr val="BCBEC4"/>
-                </a:solidFill>
-                <a:latin typeface="Consolas"/>
-              </a:rPr>
-              <a:t>        </a:t>
-            </a:r>
-            <a:r>
-              <a:rPr sz="1800">
-                <a:solidFill>
-                  <a:srgbClr val="CF8E6D"/>
-                </a:solidFill>
-                <a:latin typeface="Consolas"/>
-              </a:rPr>
-              <a:t>return</a:t>
-            </a:r>
-            <a:r>
-              <a:rPr sz="1800">
-                <a:solidFill>
-                  <a:srgbClr val="BCBEC4"/>
-                </a:solidFill>
-                <a:latin typeface="Consolas"/>
-              </a:rPr>
-              <a:t> heures * tauxHoraire;</a:t>
-            </a:r>
-          </a:p>
-          <a:p>
-            <a:pPr>
-              <a:lnSpc>
-                <a:spcPct val="100000"/>
-              </a:lnSpc>
-              <a:spcBef>
-                <a:spcPts val="0"/>
-              </a:spcBef>
-              <a:spcAft>
-                <a:spcPts val="0"/>
-              </a:spcAft>
-            </a:pPr>
-            <a:r>
-              <a:rPr sz="1800">
-                <a:solidFill>
-                  <a:srgbClr val="BCBEC4"/>
-                </a:solidFill>
-                <a:latin typeface="Consolas"/>
-              </a:rPr>
-              <a:t>    }</a:t>
-            </a:r>
-          </a:p>
-          <a:p>
-            <a:pPr>
-              <a:lnSpc>
-                <a:spcPct val="100000"/>
-              </a:lnSpc>
-              <a:spcBef>
-                <a:spcPts val="0"/>
-              </a:spcBef>
-              <a:spcAft>
-                <a:spcPts val="0"/>
-              </a:spcAft>
-            </a:pPr>
-            <a:r>
-              <a:rPr sz="1800">
-                <a:solidFill>
-                  <a:srgbClr val="BCBEC4"/>
-                </a:solidFill>
-                <a:latin typeface="Consolas"/>
-              </a:rPr>
-              <a:t>}</a:t>
-            </a:r>
-          </a:p>
-        </p:txBody>
-      </p:sp>
-      <p:sp>
-        <p:nvSpPr>
-          <p:cNvPr id="17" name="Espace réservé du numéro de diapositive 4">
-            <a:extLst>
-              <a:ext uri="{FF2B5EF4-FFF2-40B4-BE49-F238E27FC236}">
-                <a16:creationId xmlns:a16="http://schemas.microsoft.com/office/drawing/2014/main" id="{BD53DBCC-04B3-4199-D3FD-FAA13499E3E8}"/>
-              </a:ext>
-            </a:extLst>
-          </p:cNvPr>
-          <p:cNvSpPr>
-            <a:spLocks noGrp="1"/>
-          </p:cNvSpPr>
-          <p:nvPr>
-            <p:ph type="sldNum" sz="quarter" idx="4"/>
-          </p:nvPr>
-        </p:nvSpPr>
-        <p:spPr/>
-        <p:txBody>
-          <a:bodyPr/>
-          <a:lstStyle/>
-          <a:p>
-            <a:fld id="{33C783E2-4793-4F48-A271-51A73CC37D74}" type="slidenum">
-              <a:rPr lang="fr-FR" smtClean="0"/>
-              <a:t>41</a:t>
             </a:fld>
             <a:endParaRPr lang="fr-FR"/>
           </a:p>
@@ -27826,7 +27361,7 @@
           <a:p>
             <a:r>
               <a:rPr sz="4000"/>
-              <a:t>Implémenter sans définir</a:t>
+              <a:t>Où placer chaque champ</a:t>
             </a:r>
           </a:p>
         </p:txBody>
@@ -27844,7 +27379,7 @@
         <p:spPr>
           <a:xfrm>
             <a:off x="640080" y="1371600"/>
-            <a:ext cx="10881360" cy="2499359"/>
+            <a:ext cx="10881360" cy="1798320"/>
           </a:xfrm>
         </p:spPr>
         <p:txBody>
@@ -27858,8 +27393,8 @@
               <a:buNone/>
             </a:pPr>
             <a:r>
-              <a:rPr sz="2600"/>
-              <a:t>Une classe abstraite peut implémenter une interface sans écrire ses méthodes</a:t>
+              <a:rPr sz="2800"/>
+              <a:t>Un champ se déclare à l'étage où il devient commun</a:t>
             </a:r>
           </a:p>
           <a:p>
@@ -27870,8 +27405,8 @@
               <a:buNone/>
             </a:pPr>
             <a:r>
-              <a:rPr sz="2600"/>
-              <a:t>La promesse est reportée sur les sous-classes concrètes</a:t>
+              <a:rPr sz="2800"/>
+              <a:t>Trop haut, il encombre qui n'en a pas l'usage</a:t>
             </a:r>
           </a:p>
           <a:p>
@@ -27882,34 +27417,8 @@
               <a:buNone/>
             </a:pPr>
             <a:r>
-              <a:rPr sz="2600"/>
-              <a:t>La méthode </a:t>
-            </a:r>
-            <a:r>
-              <a:rPr sz="2200">
-                <a:solidFill>
-                  <a:schemeClr val="accent4"/>
-                </a:solidFill>
-                <a:latin typeface="Consolas"/>
-              </a:rPr>
-              <a:t>facture</a:t>
-            </a:r>
-            <a:r>
-              <a:rPr sz="2600"/>
-              <a:t> appelle </a:t>
-            </a:r>
-            <a:r>
-              <a:rPr sz="2200">
-                <a:solidFill>
-                  <a:schemeClr val="accent4"/>
-                </a:solidFill>
-                <a:latin typeface="Consolas"/>
-              </a:rPr>
-              <a:t>montant</a:t>
-            </a:r>
-            <a:r>
-              <a:rPr sz="2600"/>
-              <a:t>, qui n'existe encore nulle part</a:t>
+              <a:rPr sz="2800"/>
+              <a:t>Trop bas, il s'écrit deux fois</a:t>
             </a:r>
           </a:p>
         </p:txBody>
@@ -27922,12 +27431,12 @@
         </p:nvSpPr>
         <p:spPr>
           <a:xfrm>
-            <a:off x="2032000" y="4008119"/>
-            <a:ext cx="8128000" cy="1920239"/>
+            <a:off x="2451100" y="3307080"/>
+            <a:ext cx="7289800" cy="2743200"/>
           </a:xfrm>
           <a:prstGeom prst="roundRect">
             <a:avLst>
-              <a:gd name="adj" fmla="val 4761"/>
+              <a:gd name="adj" fmla="val 3333"/>
             </a:avLst>
           </a:prstGeom>
           <a:solidFill>
@@ -28008,7 +27517,7 @@
                 </a:solidFill>
                 <a:latin typeface="Consolas"/>
               </a:rPr>
-              <a:t> Prestation </a:t>
+              <a:t> Horaire </a:t>
             </a:r>
             <a:r>
               <a:rPr sz="1800">
@@ -28017,7 +27526,7 @@
                 </a:solidFill>
                 <a:latin typeface="Consolas"/>
               </a:rPr>
-              <a:t>implements</a:t>
+              <a:t>extends</a:t>
             </a:r>
             <a:r>
               <a:rPr sz="1800">
@@ -28026,7 +27535,7 @@
                 </a:solidFill>
                 <a:latin typeface="Consolas"/>
               </a:rPr>
-              <a:t> Facturable {</a:t>
+              <a:t> Prestation {</a:t>
             </a:r>
           </a:p>
           <a:p>
@@ -28079,7 +27588,7 @@
                 </a:solidFill>
                 <a:latin typeface="Consolas"/>
               </a:rPr>
-              <a:t>public</a:t>
+              <a:t>private</a:t>
             </a:r>
             <a:r>
               <a:rPr sz="1800">
@@ -28088,16 +27597,16 @@
                 </a:solidFill>
                 <a:latin typeface="Consolas"/>
               </a:rPr>
-              <a:t> String </a:t>
+              <a:t> </a:t>
             </a:r>
             <a:r>
               <a:rPr sz="1800">
                 <a:solidFill>
-                  <a:srgbClr val="56A8F5"/>
-                </a:solidFill>
-                <a:latin typeface="Consolas"/>
-              </a:rPr>
-              <a:t>facture</a:t>
+                  <a:srgbClr val="CF8E6D"/>
+                </a:solidFill>
+                <a:latin typeface="Consolas"/>
+              </a:rPr>
+              <a:t>final</a:t>
             </a:r>
             <a:r>
               <a:rPr sz="1800">
@@ -28106,7 +27615,25 @@
                 </a:solidFill>
                 <a:latin typeface="Consolas"/>
               </a:rPr>
-              <a:t>() {</a:t>
+              <a:t> </a:t>
+            </a:r>
+            <a:r>
+              <a:rPr sz="1800">
+                <a:solidFill>
+                  <a:srgbClr val="CF8E6D"/>
+                </a:solidFill>
+                <a:latin typeface="Consolas"/>
+              </a:rPr>
+              <a:t>double</a:t>
+            </a:r>
+            <a:r>
+              <a:rPr sz="1800">
+                <a:solidFill>
+                  <a:srgbClr val="BCBEC4"/>
+                </a:solidFill>
+                <a:latin typeface="Consolas"/>
+              </a:rPr>
+              <a:t> tauxHoraire;</a:t>
             </a:r>
           </a:p>
           <a:p>
@@ -28128,6 +27655,180 @@
                 </a:solidFill>
                 <a:latin typeface="Consolas"/>
               </a:rPr>
+              <a:t>    </a:t>
+            </a:r>
+            <a:r>
+              <a:rPr sz="1800">
+                <a:solidFill>
+                  <a:srgbClr val="CF8E6D"/>
+                </a:solidFill>
+                <a:latin typeface="Consolas"/>
+              </a:rPr>
+              <a:t>private</a:t>
+            </a:r>
+            <a:r>
+              <a:rPr sz="1800">
+                <a:solidFill>
+                  <a:srgbClr val="BCBEC4"/>
+                </a:solidFill>
+                <a:latin typeface="Consolas"/>
+              </a:rPr>
+              <a:t> </a:t>
+            </a:r>
+            <a:r>
+              <a:rPr sz="1800">
+                <a:solidFill>
+                  <a:srgbClr val="CF8E6D"/>
+                </a:solidFill>
+                <a:latin typeface="Consolas"/>
+              </a:rPr>
+              <a:t>final</a:t>
+            </a:r>
+            <a:r>
+              <a:rPr sz="1800">
+                <a:solidFill>
+                  <a:srgbClr val="BCBEC4"/>
+                </a:solidFill>
+                <a:latin typeface="Consolas"/>
+              </a:rPr>
+              <a:t> </a:t>
+            </a:r>
+            <a:r>
+              <a:rPr sz="1800">
+                <a:solidFill>
+                  <a:srgbClr val="CF8E6D"/>
+                </a:solidFill>
+                <a:latin typeface="Consolas"/>
+              </a:rPr>
+              <a:t>int</a:t>
+            </a:r>
+            <a:r>
+              <a:rPr sz="1800">
+                <a:solidFill>
+                  <a:srgbClr val="BCBEC4"/>
+                </a:solidFill>
+                <a:latin typeface="Consolas"/>
+              </a:rPr>
+              <a:t> heures;</a:t>
+            </a:r>
+          </a:p>
+          <a:p>
+            <a:pPr>
+              <a:lnSpc>
+                <a:spcPct val="100000"/>
+              </a:lnSpc>
+              <a:spcBef>
+                <a:spcPts val="0"/>
+              </a:spcBef>
+              <a:spcAft>
+                <a:spcPts val="0"/>
+              </a:spcAft>
+            </a:pPr>
+            <a:r>
+              <a:rPr sz="1800">
+                <a:solidFill>
+                  <a:srgbClr val="BCBEC4"/>
+                </a:solidFill>
+                <a:latin typeface="Consolas"/>
+              </a:rPr>
+              <a:t> </a:t>
+            </a:r>
+          </a:p>
+          <a:p>
+            <a:pPr>
+              <a:lnSpc>
+                <a:spcPct val="100000"/>
+              </a:lnSpc>
+              <a:spcBef>
+                <a:spcPts val="0"/>
+              </a:spcBef>
+              <a:spcAft>
+                <a:spcPts val="0"/>
+              </a:spcAft>
+            </a:pPr>
+            <a:r>
+              <a:rPr sz="1800">
+                <a:solidFill>
+                  <a:srgbClr val="BCBEC4"/>
+                </a:solidFill>
+                <a:latin typeface="Consolas"/>
+              </a:rPr>
+              <a:t>    </a:t>
+            </a:r>
+            <a:r>
+              <a:rPr sz="1800">
+                <a:solidFill>
+                  <a:srgbClr val="CF8E6D"/>
+                </a:solidFill>
+                <a:latin typeface="Consolas"/>
+              </a:rPr>
+              <a:t>protected</a:t>
+            </a:r>
+            <a:r>
+              <a:rPr sz="1800">
+                <a:solidFill>
+                  <a:srgbClr val="BCBEC4"/>
+                </a:solidFill>
+                <a:latin typeface="Consolas"/>
+              </a:rPr>
+              <a:t> </a:t>
+            </a:r>
+            <a:r>
+              <a:rPr sz="1800">
+                <a:solidFill>
+                  <a:srgbClr val="CF8E6D"/>
+                </a:solidFill>
+                <a:latin typeface="Consolas"/>
+              </a:rPr>
+              <a:t>double</a:t>
+            </a:r>
+            <a:r>
+              <a:rPr sz="1800">
+                <a:solidFill>
+                  <a:srgbClr val="BCBEC4"/>
+                </a:solidFill>
+                <a:latin typeface="Consolas"/>
+              </a:rPr>
+              <a:t> </a:t>
+            </a:r>
+            <a:r>
+              <a:rPr sz="1800">
+                <a:solidFill>
+                  <a:srgbClr val="56A8F5"/>
+                </a:solidFill>
+                <a:latin typeface="Consolas"/>
+              </a:rPr>
+              <a:t>base</a:t>
+            </a:r>
+            <a:r>
+              <a:rPr sz="1800">
+                <a:solidFill>
+                  <a:srgbClr val="BCBEC4"/>
+                </a:solidFill>
+                <a:latin typeface="Consolas"/>
+              </a:rPr>
+              <a:t>() {</a:t>
+            </a:r>
+          </a:p>
+          <a:p>
+            <a:pPr>
+              <a:lnSpc>
+                <a:spcPct val="100000"/>
+              </a:lnSpc>
+              <a:spcBef>
+                <a:spcPts val="0"/>
+              </a:spcBef>
+              <a:spcAft>
+                <a:spcPts val="0"/>
+              </a:spcAft>
+            </a:pPr>
+            <a:r>
+              <a:rPr sz="1800">
+                <a:solidFill>
+                  <a:srgbClr val="BCBEC4"/>
+                </a:solidFill>
+                <a:latin typeface="Consolas"/>
+              </a:rPr>
               <a:t>        </a:t>
             </a:r>
             <a:r>
@@ -28146,61 +27847,7 @@
                 </a:solidFill>
                 <a:latin typeface="Consolas"/>
               </a:rPr>
-              <a:t> client + </a:t>
-            </a:r>
-            <a:r>
-              <a:rPr sz="1800">
-                <a:solidFill>
-                  <a:srgbClr val="6AAB73"/>
-                </a:solidFill>
-                <a:latin typeface="Consolas"/>
-              </a:rPr>
-              <a:t>" : "</a:t>
-            </a:r>
-            <a:r>
-              <a:rPr sz="1800">
-                <a:solidFill>
-                  <a:srgbClr val="BCBEC4"/>
-                </a:solidFill>
-                <a:latin typeface="Consolas"/>
-              </a:rPr>
-              <a:t> + </a:t>
-            </a:r>
-            <a:r>
-              <a:rPr sz="1800">
-                <a:solidFill>
-                  <a:srgbClr val="56A8F5"/>
-                </a:solidFill>
-                <a:latin typeface="Consolas"/>
-              </a:rPr>
-              <a:t>montant</a:t>
-            </a:r>
-            <a:r>
-              <a:rPr sz="1800">
-                <a:solidFill>
-                  <a:srgbClr val="BCBEC4"/>
-                </a:solidFill>
-                <a:latin typeface="Consolas"/>
-              </a:rPr>
-              <a:t>() + </a:t>
-            </a:r>
-            <a:r>
-              <a:rPr sz="1800">
-                <a:solidFill>
-                  <a:srgbClr val="6AAB73"/>
-                </a:solidFill>
-                <a:latin typeface="Consolas"/>
-              </a:rPr>
-              <a:t>" EUR"</a:t>
-            </a:r>
-            <a:r>
-              <a:rPr sz="1800">
-                <a:solidFill>
-                  <a:srgbClr val="BCBEC4"/>
-                </a:solidFill>
-                <a:latin typeface="Consolas"/>
-              </a:rPr>
-              <a:t>;</a:t>
+              <a:t> heures * tauxHoraire;</a:t>
             </a:r>
           </a:p>
           <a:p>
@@ -28272,7 +27919,7 @@
           <a:p>
             <a:fld id="{33C783E2-4793-4F48-A271-51A73CC37D74}" type="slidenum">
               <a:rPr lang="fr-FR" smtClean="0"/>
-              <a:t>42</a:t>
+              <a:t>41</a:t>
             </a:fld>
             <a:endParaRPr lang="fr-FR"/>
           </a:p>
@@ -28450,6 +28097,630 @@
           <a:p>
             <a:r>
               <a:rPr sz="4000"/>
+              <a:t>Implémenter sans définir</a:t>
+            </a:r>
+          </a:p>
+        </p:txBody>
+      </p:sp>
+      <p:sp>
+        <p:nvSpPr>
+          <p:cNvPr id="3" name="Content Placeholder 2"/>
+          <p:cNvSpPr>
+            <a:spLocks noGrp="1"/>
+          </p:cNvSpPr>
+          <p:nvPr>
+            <p:ph idx="1"/>
+          </p:nvPr>
+        </p:nvSpPr>
+        <p:spPr>
+          <a:xfrm>
+            <a:off x="640080" y="1371600"/>
+            <a:ext cx="10881360" cy="2499359"/>
+          </a:xfrm>
+        </p:spPr>
+        <p:txBody>
+          <a:bodyPr/>
+          <a:lstStyle/>
+          <a:p>
+            <a:pPr marL="0" indent="0">
+              <a:spcAft>
+                <a:spcPts val="1000"/>
+              </a:spcAft>
+              <a:buNone/>
+            </a:pPr>
+            <a:r>
+              <a:rPr sz="2600"/>
+              <a:t>Une classe abstraite peut implémenter une interface sans écrire ses méthodes</a:t>
+            </a:r>
+          </a:p>
+          <a:p>
+            <a:pPr marL="0" indent="0">
+              <a:spcAft>
+                <a:spcPts val="1000"/>
+              </a:spcAft>
+              <a:buNone/>
+            </a:pPr>
+            <a:r>
+              <a:rPr sz="2600"/>
+              <a:t>La promesse est reportée sur les sous-classes concrètes</a:t>
+            </a:r>
+          </a:p>
+          <a:p>
+            <a:pPr marL="0" indent="0">
+              <a:spcAft>
+                <a:spcPts val="1000"/>
+              </a:spcAft>
+              <a:buNone/>
+            </a:pPr>
+            <a:r>
+              <a:rPr sz="2600"/>
+              <a:t>La méthode </a:t>
+            </a:r>
+            <a:r>
+              <a:rPr sz="2200">
+                <a:solidFill>
+                  <a:schemeClr val="accent4"/>
+                </a:solidFill>
+                <a:latin typeface="Consolas"/>
+              </a:rPr>
+              <a:t>facture</a:t>
+            </a:r>
+            <a:r>
+              <a:rPr sz="2600"/>
+              <a:t> appelle </a:t>
+            </a:r>
+            <a:r>
+              <a:rPr sz="2200">
+                <a:solidFill>
+                  <a:schemeClr val="accent4"/>
+                </a:solidFill>
+                <a:latin typeface="Consolas"/>
+              </a:rPr>
+              <a:t>montant</a:t>
+            </a:r>
+            <a:r>
+              <a:rPr sz="2600"/>
+              <a:t>, qui n'existe encore nulle part</a:t>
+            </a:r>
+          </a:p>
+        </p:txBody>
+      </p:sp>
+      <p:sp>
+        <p:nvSpPr>
+          <p:cNvPr id="4" name="Code"/>
+          <p:cNvSpPr txBox="1"/>
+          <p:nvPr/>
+        </p:nvSpPr>
+        <p:spPr>
+          <a:xfrm>
+            <a:off x="2032000" y="4008119"/>
+            <a:ext cx="8128000" cy="1920239"/>
+          </a:xfrm>
+          <a:prstGeom prst="roundRect">
+            <a:avLst>
+              <a:gd name="adj" fmla="val 4761"/>
+            </a:avLst>
+          </a:prstGeom>
+          <a:solidFill>
+            <a:srgbClr val="1D1F22"/>
+          </a:solidFill>
+          <a:effectLst>
+            <a:outerShdw blurRad="50800" dist="38100" dir="2700000" algn="tl" rotWithShape="0">
+              <a:prstClr val="black">
+                <a:alpha val="40000"/>
+              </a:prstClr>
+            </a:outerShdw>
+          </a:effectLst>
+        </p:spPr>
+        <p:txBody>
+          <a:bodyPr wrap="none" lIns="137160" tIns="91440" rIns="137160" bIns="91440"/>
+          <a:lstStyle/>
+          <a:p>
+            <a:pPr>
+              <a:lnSpc>
+                <a:spcPct val="100000"/>
+              </a:lnSpc>
+              <a:spcBef>
+                <a:spcPts val="0"/>
+              </a:spcBef>
+              <a:spcAft>
+                <a:spcPts val="0"/>
+              </a:spcAft>
+            </a:pPr>
+            <a:r>
+              <a:rPr sz="1800">
+                <a:solidFill>
+                  <a:srgbClr val="CF8E6D"/>
+                </a:solidFill>
+                <a:latin typeface="Consolas"/>
+              </a:rPr>
+              <a:t>public</a:t>
+            </a:r>
+            <a:r>
+              <a:rPr sz="1800">
+                <a:solidFill>
+                  <a:srgbClr val="BCBEC4"/>
+                </a:solidFill>
+                <a:latin typeface="Consolas"/>
+              </a:rPr>
+              <a:t> </a:t>
+            </a:r>
+            <a:r>
+              <a:rPr sz="1800">
+                <a:solidFill>
+                  <a:srgbClr val="CF8E6D"/>
+                </a:solidFill>
+                <a:latin typeface="Consolas"/>
+              </a:rPr>
+              <a:t>abstract</a:t>
+            </a:r>
+            <a:r>
+              <a:rPr sz="1800">
+                <a:solidFill>
+                  <a:srgbClr val="BCBEC4"/>
+                </a:solidFill>
+                <a:latin typeface="Consolas"/>
+              </a:rPr>
+              <a:t> </a:t>
+            </a:r>
+            <a:r>
+              <a:rPr sz="1800">
+                <a:solidFill>
+                  <a:srgbClr val="CF8E6D"/>
+                </a:solidFill>
+                <a:latin typeface="Consolas"/>
+              </a:rPr>
+              <a:t>class</a:t>
+            </a:r>
+            <a:r>
+              <a:rPr sz="1800">
+                <a:solidFill>
+                  <a:srgbClr val="BCBEC4"/>
+                </a:solidFill>
+                <a:latin typeface="Consolas"/>
+              </a:rPr>
+              <a:t> Prestation </a:t>
+            </a:r>
+            <a:r>
+              <a:rPr sz="1800">
+                <a:solidFill>
+                  <a:srgbClr val="CF8E6D"/>
+                </a:solidFill>
+                <a:latin typeface="Consolas"/>
+              </a:rPr>
+              <a:t>implements</a:t>
+            </a:r>
+            <a:r>
+              <a:rPr sz="1800">
+                <a:solidFill>
+                  <a:srgbClr val="BCBEC4"/>
+                </a:solidFill>
+                <a:latin typeface="Consolas"/>
+              </a:rPr>
+              <a:t> Facturable {</a:t>
+            </a:r>
+          </a:p>
+          <a:p>
+            <a:pPr>
+              <a:lnSpc>
+                <a:spcPct val="100000"/>
+              </a:lnSpc>
+              <a:spcBef>
+                <a:spcPts val="0"/>
+              </a:spcBef>
+              <a:spcAft>
+                <a:spcPts val="0"/>
+              </a:spcAft>
+            </a:pPr>
+            <a:r>
+              <a:rPr sz="1800">
+                <a:solidFill>
+                  <a:srgbClr val="BCBEC4"/>
+                </a:solidFill>
+                <a:latin typeface="Consolas"/>
+              </a:rPr>
+              <a:t> </a:t>
+            </a:r>
+          </a:p>
+          <a:p>
+            <a:pPr>
+              <a:lnSpc>
+                <a:spcPct val="100000"/>
+              </a:lnSpc>
+              <a:spcBef>
+                <a:spcPts val="0"/>
+              </a:spcBef>
+              <a:spcAft>
+                <a:spcPts val="0"/>
+              </a:spcAft>
+            </a:pPr>
+            <a:r>
+              <a:rPr sz="1800">
+                <a:solidFill>
+                  <a:srgbClr val="BCBEC4"/>
+                </a:solidFill>
+                <a:latin typeface="Consolas"/>
+              </a:rPr>
+              <a:t>    </a:t>
+            </a:r>
+            <a:r>
+              <a:rPr sz="1800">
+                <a:solidFill>
+                  <a:srgbClr val="CF8E6D"/>
+                </a:solidFill>
+                <a:latin typeface="Consolas"/>
+              </a:rPr>
+              <a:t>public</a:t>
+            </a:r>
+            <a:r>
+              <a:rPr sz="1800">
+                <a:solidFill>
+                  <a:srgbClr val="BCBEC4"/>
+                </a:solidFill>
+                <a:latin typeface="Consolas"/>
+              </a:rPr>
+              <a:t> String </a:t>
+            </a:r>
+            <a:r>
+              <a:rPr sz="1800">
+                <a:solidFill>
+                  <a:srgbClr val="56A8F5"/>
+                </a:solidFill>
+                <a:latin typeface="Consolas"/>
+              </a:rPr>
+              <a:t>facture</a:t>
+            </a:r>
+            <a:r>
+              <a:rPr sz="1800">
+                <a:solidFill>
+                  <a:srgbClr val="BCBEC4"/>
+                </a:solidFill>
+                <a:latin typeface="Consolas"/>
+              </a:rPr>
+              <a:t>() {</a:t>
+            </a:r>
+          </a:p>
+          <a:p>
+            <a:pPr>
+              <a:lnSpc>
+                <a:spcPct val="100000"/>
+              </a:lnSpc>
+              <a:spcBef>
+                <a:spcPts val="0"/>
+              </a:spcBef>
+              <a:spcAft>
+                <a:spcPts val="0"/>
+              </a:spcAft>
+            </a:pPr>
+            <a:r>
+              <a:rPr sz="1800">
+                <a:solidFill>
+                  <a:srgbClr val="BCBEC4"/>
+                </a:solidFill>
+                <a:latin typeface="Consolas"/>
+              </a:rPr>
+              <a:t>        </a:t>
+            </a:r>
+            <a:r>
+              <a:rPr sz="1800">
+                <a:solidFill>
+                  <a:srgbClr val="CF8E6D"/>
+                </a:solidFill>
+                <a:latin typeface="Consolas"/>
+              </a:rPr>
+              <a:t>return</a:t>
+            </a:r>
+            <a:r>
+              <a:rPr sz="1800">
+                <a:solidFill>
+                  <a:srgbClr val="BCBEC4"/>
+                </a:solidFill>
+                <a:latin typeface="Consolas"/>
+              </a:rPr>
+              <a:t> client + </a:t>
+            </a:r>
+            <a:r>
+              <a:rPr sz="1800">
+                <a:solidFill>
+                  <a:srgbClr val="6AAB73"/>
+                </a:solidFill>
+                <a:latin typeface="Consolas"/>
+              </a:rPr>
+              <a:t>" : "</a:t>
+            </a:r>
+            <a:r>
+              <a:rPr sz="1800">
+                <a:solidFill>
+                  <a:srgbClr val="BCBEC4"/>
+                </a:solidFill>
+                <a:latin typeface="Consolas"/>
+              </a:rPr>
+              <a:t> + </a:t>
+            </a:r>
+            <a:r>
+              <a:rPr sz="1800">
+                <a:solidFill>
+                  <a:srgbClr val="56A8F5"/>
+                </a:solidFill>
+                <a:latin typeface="Consolas"/>
+              </a:rPr>
+              <a:t>montant</a:t>
+            </a:r>
+            <a:r>
+              <a:rPr sz="1800">
+                <a:solidFill>
+                  <a:srgbClr val="BCBEC4"/>
+                </a:solidFill>
+                <a:latin typeface="Consolas"/>
+              </a:rPr>
+              <a:t>() + </a:t>
+            </a:r>
+            <a:r>
+              <a:rPr sz="1800">
+                <a:solidFill>
+                  <a:srgbClr val="6AAB73"/>
+                </a:solidFill>
+                <a:latin typeface="Consolas"/>
+              </a:rPr>
+              <a:t>" EUR"</a:t>
+            </a:r>
+            <a:r>
+              <a:rPr sz="1800">
+                <a:solidFill>
+                  <a:srgbClr val="BCBEC4"/>
+                </a:solidFill>
+                <a:latin typeface="Consolas"/>
+              </a:rPr>
+              <a:t>;</a:t>
+            </a:r>
+          </a:p>
+          <a:p>
+            <a:pPr>
+              <a:lnSpc>
+                <a:spcPct val="100000"/>
+              </a:lnSpc>
+              <a:spcBef>
+                <a:spcPts val="0"/>
+              </a:spcBef>
+              <a:spcAft>
+                <a:spcPts val="0"/>
+              </a:spcAft>
+            </a:pPr>
+            <a:r>
+              <a:rPr sz="1800">
+                <a:solidFill>
+                  <a:srgbClr val="BCBEC4"/>
+                </a:solidFill>
+                <a:latin typeface="Consolas"/>
+              </a:rPr>
+              <a:t>    }</a:t>
+            </a:r>
+          </a:p>
+          <a:p>
+            <a:pPr>
+              <a:lnSpc>
+                <a:spcPct val="100000"/>
+              </a:lnSpc>
+              <a:spcBef>
+                <a:spcPts val="0"/>
+              </a:spcBef>
+              <a:spcAft>
+                <a:spcPts val="0"/>
+              </a:spcAft>
+            </a:pPr>
+            <a:r>
+              <a:rPr sz="1800">
+                <a:solidFill>
+                  <a:srgbClr val="BCBEC4"/>
+                </a:solidFill>
+                <a:latin typeface="Consolas"/>
+              </a:rPr>
+              <a:t>}</a:t>
+            </a:r>
+          </a:p>
+        </p:txBody>
+      </p:sp>
+      <p:sp>
+        <p:nvSpPr>
+          <p:cNvPr id="17" name="Espace réservé du numéro de diapositive 4">
+            <a:extLst>
+              <a:ext uri="{FF2B5EF4-FFF2-40B4-BE49-F238E27FC236}">
+                <a16:creationId xmlns:a16="http://schemas.microsoft.com/office/drawing/2014/main" id="{BD53DBCC-04B3-4199-D3FD-FAA13499E3E8}"/>
+              </a:ext>
+            </a:extLst>
+          </p:cNvPr>
+          <p:cNvSpPr>
+            <a:spLocks noGrp="1"/>
+          </p:cNvSpPr>
+          <p:nvPr>
+            <p:ph type="sldNum" sz="quarter" idx="4"/>
+          </p:nvPr>
+        </p:nvSpPr>
+        <p:spPr/>
+        <p:txBody>
+          <a:bodyPr/>
+          <a:lstStyle/>
+          <a:p>
+            <a:fld id="{33C783E2-4793-4F48-A271-51A73CC37D74}" type="slidenum">
+              <a:rPr lang="fr-FR" smtClean="0"/>
+              <a:t>42</a:t>
+            </a:fld>
+            <a:endParaRPr lang="fr-FR"/>
+          </a:p>
+        </p:txBody>
+      </p:sp>
+      <p:sp>
+        <p:nvSpPr>
+          <p:cNvPr id="18" name="Repere de section"/>
+          <p:cNvSpPr txBox="1"/>
+          <p:nvPr/>
+        </p:nvSpPr>
+        <p:spPr>
+          <a:xfrm>
+            <a:off x="6583680" y="6382512"/>
+            <a:ext cx="4480560" cy="320040"/>
+          </a:xfrm>
+          <a:prstGeom prst="rect">
+            <a:avLst/>
+          </a:prstGeom>
+          <a:noFill/>
+        </p:spPr>
+        <p:txBody>
+          <a:bodyPr wrap="none" tIns="0" bIns="0">
+            <a:spAutoFit/>
+          </a:bodyPr>
+          <a:lstStyle/>
+          <a:p>
+            <a:pPr algn="r"/>
+            <a:r>
+              <a:rPr sz="1100">
+                <a:solidFill>
+                  <a:srgbClr val="BCBEC4"/>
+                </a:solidFill>
+              </a:rPr>
+              <a:t>ABS · </a:t>
+            </a:r>
+            <a:r>
+              <a:rPr sz="1100" b="1">
+                <a:solidFill>
+                  <a:schemeClr val="accent4"/>
+                </a:solidFill>
+              </a:rPr>
+              <a:t>7. Deux étages</a:t>
+            </a:r>
+          </a:p>
+        </p:txBody>
+      </p:sp>
+    </p:spTree>
+  </p:cSld>
+  <p:clrMapOvr>
+    <a:masterClrMapping/>
+  </p:clrMapOvr>
+  <p:timing>
+    <p:tnLst>
+      <p:par>
+        <p:cTn id="1" dur="indefinite" restart="never" nodeType="tmRoot">
+          <p:childTnLst>
+            <p:seq concurrent="1" nextAc="seek">
+              <p:cTn id="2" dur="indefinite" nodeType="mainSeq">
+                <p:childTnLst>
+                  <p:par>
+                    <p:cTn id="3" fill="hold">
+                      <p:stCondLst>
+                        <p:cond delay="indefinite"/>
+                      </p:stCondLst>
+                      <p:childTnLst>
+                        <p:par>
+                          <p:cTn id="4" fill="hold">
+                            <p:stCondLst>
+                              <p:cond delay="0"/>
+                            </p:stCondLst>
+                            <p:childTnLst>
+                              <p:par>
+                                <p:cTn id="5" presetID="10" presetClass="entr" presetSubtype="0" fill="hold" grpId="0" nodeType="clickEffect">
+                                  <p:stCondLst>
+                                    <p:cond delay="0"/>
+                                  </p:stCondLst>
+                                  <p:childTnLst>
+                                    <p:set>
+                                      <p:cBhvr>
+                                        <p:cTn id="6" dur="1" fill="hold">
+                                          <p:stCondLst>
+                                            <p:cond delay="0"/>
+                                          </p:stCondLst>
+                                        </p:cTn>
+                                        <p:tgtEl>
+                                          <p:spTgt spid="4"/>
+                                        </p:tgtEl>
+                                        <p:attrNameLst>
+                                          <p:attrName>style.visibility</p:attrName>
+                                        </p:attrNameLst>
+                                      </p:cBhvr>
+                                      <p:to>
+                                        <p:strVal val="visible"/>
+                                      </p:to>
+                                    </p:set>
+                                    <p:animEffect transition="in" filter="fade">
+                                      <p:cBhvr>
+                                        <p:cTn id="7" dur="500"/>
+                                        <p:tgtEl>
+                                          <p:spTgt spid="4"/>
+                                        </p:tgtEl>
+                                      </p:cBhvr>
+                                    </p:animEffect>
+                                  </p:childTnLst>
+                                </p:cTn>
+                              </p:par>
+                            </p:childTnLst>
+                          </p:cTn>
+                        </p:par>
+                      </p:childTnLst>
+                    </p:cTn>
+                  </p:par>
+                </p:childTnLst>
+              </p:cTn>
+              <p:prevCondLst>
+                <p:cond evt="onPrev" delay="0">
+                  <p:tgtEl>
+                    <p:sldTgt/>
+                  </p:tgtEl>
+                </p:cond>
+              </p:prevCondLst>
+              <p:nextCondLst>
+                <p:cond evt="onNext" delay="0">
+                  <p:tgtEl>
+                    <p:sldTgt/>
+                  </p:tgtEl>
+                </p:cond>
+              </p:nextCondLst>
+            </p:seq>
+          </p:childTnLst>
+        </p:cTn>
+      </p:par>
+    </p:tnLst>
+    <p:bldLst>
+      <p:bldP spid="4" grpId="0" animBg="1"/>
+    </p:bldLst>
+  </p:timing>
+</p:sld>
+</file>
+
+<file path=ppt/slides/slide44.xml><?xml version="1.0" encoding="utf-8"?>
+<p:sld xmlns:a="http://schemas.openxmlformats.org/drawingml/2006/main" xmlns:r="http://schemas.openxmlformats.org/officeDocument/2006/relationships" xmlns:p="http://schemas.openxmlformats.org/presentationml/2006/main">
+  <p:cSld>
+    <p:spTree>
+      <p:nvGrpSpPr>
+        <p:cNvPr id="1" name=""/>
+        <p:cNvGrpSpPr/>
+        <p:nvPr/>
+      </p:nvGrpSpPr>
+      <p:grpSpPr>
+        <a:xfrm>
+          <a:off x="0" y="0"/>
+          <a:ext cx="0" cy="0"/>
+          <a:chOff x="0" y="0"/>
+          <a:chExt cx="0" cy="0"/>
+        </a:xfrm>
+      </p:grpSpPr>
+      <p:sp>
+        <p:nvSpPr>
+          <p:cNvPr id="2" name="Title 1"/>
+          <p:cNvSpPr>
+            <a:spLocks noGrp="1"/>
+          </p:cNvSpPr>
+          <p:nvPr>
+            <p:ph type="title"/>
+          </p:nvPr>
+        </p:nvSpPr>
+        <p:spPr/>
+        <p:txBody>
+          <a:bodyPr>
+            <a:noAutofit/>
+          </a:bodyPr>
+          <a:lstStyle/>
+          <a:p>
+            <a:r>
+              <a:rPr sz="4000"/>
               <a:t>Exercices</a:t>
             </a:r>
           </a:p>
@@ -28732,7 +29003,7 @@
 </p:sld>
 </file>
 
-<file path=ppt/slides/slide44.xml><?xml version="1.0" encoding="utf-8"?>
+<file path=ppt/slides/slide45.xml><?xml version="1.0" encoding="utf-8"?>
 <p:sld xmlns:a="http://schemas.openxmlformats.org/drawingml/2006/main" xmlns:r="http://schemas.openxmlformats.org/officeDocument/2006/relationships" xmlns:p="http://schemas.openxmlformats.org/presentationml/2006/main">
   <p:cSld>
     <p:spTree>
@@ -28893,7 +29164,7 @@
 </p:sld>
 </file>
 
-<file path=ppt/slides/slide45.xml><?xml version="1.0" encoding="utf-8"?>
+<file path=ppt/slides/slide46.xml><?xml version="1.0" encoding="utf-8"?>
 <p:sld xmlns:a="http://schemas.openxmlformats.org/drawingml/2006/main" xmlns:r="http://schemas.openxmlformats.org/officeDocument/2006/relationships" xmlns:p="http://schemas.openxmlformats.org/presentationml/2006/main">
   <p:cSld>
     <p:spTree>
@@ -29480,7 +29751,7 @@
 </p:sld>
 </file>
 
-<file path=ppt/slides/slide46.xml><?xml version="1.0" encoding="utf-8"?>
+<file path=ppt/slides/slide47.xml><?xml version="1.0" encoding="utf-8"?>
 <p:sld xmlns:a="http://schemas.openxmlformats.org/drawingml/2006/main" xmlns:r="http://schemas.openxmlformats.org/officeDocument/2006/relationships" xmlns:p="http://schemas.openxmlformats.org/presentationml/2006/main">
   <p:cSld>
     <p:spTree>
@@ -33267,6 +33538,7 @@
           <a:lstStyle/>
           <a:p>
             <a:r>
+              <a:rPr/>
               <a:t>A une personne, ou est une personne ?</a:t>
             </a:r>
           </a:p>

</xml_diff>